<commit_message>
Update modeling, EDA, and report deliverables
</commit_message>
<xml_diff>
--- a/6_Presentation/Presentation_Slides.pptx
+++ b/6_Presentation/Presentation_Slides.pptx
@@ -4,24 +4,21 @@
   <p:sldMasterIdLst>
     <p:sldMasterId id="2147483648" r:id="rId1"/>
   </p:sldMasterIdLst>
-  <p:notesMasterIdLst>
-    <p:notesMasterId r:id="rId14"/>
-  </p:notesMasterIdLst>
   <p:sldIdLst>
-    <p:sldId id="256" r:id="rId2"/>
-    <p:sldId id="257" r:id="rId3"/>
-    <p:sldId id="258" r:id="rId4"/>
-    <p:sldId id="259" r:id="rId5"/>
-    <p:sldId id="260" r:id="rId6"/>
-    <p:sldId id="261" r:id="rId7"/>
-    <p:sldId id="262" r:id="rId8"/>
-    <p:sldId id="263" r:id="rId9"/>
-    <p:sldId id="264" r:id="rId10"/>
-    <p:sldId id="265" r:id="rId11"/>
-    <p:sldId id="266" r:id="rId12"/>
-    <p:sldId id="267" r:id="rId13"/>
+    <p:sldId id="256" r:id="rId7"/>
+    <p:sldId id="257" r:id="rId9"/>
+    <p:sldId id="258" r:id="rId10"/>
+    <p:sldId id="259" r:id="rId11"/>
+    <p:sldId id="260" r:id="rId12"/>
+    <p:sldId id="261" r:id="rId13"/>
+    <p:sldId id="262" r:id="rId14"/>
+    <p:sldId id="263" r:id="rId15"/>
+    <p:sldId id="264" r:id="rId16"/>
+    <p:sldId id="265" r:id="rId17"/>
+    <p:sldId id="266" r:id="rId18"/>
+    <p:sldId id="267" r:id="rId19"/>
   </p:sldIdLst>
-  <p:sldSz cx="12192000" cy="6858000"/>
+  <p:sldSz cx="12191695" cy="6858000" type="screen4x3"/>
   <p:notesSz cx="6858000" cy="9144000"/>
   <p:defaultTextStyle>
     <a:defPPr>
@@ -118,27 +115,11 @@
       </a:defRPr>
     </a:lvl9pPr>
   </p:defaultTextStyle>
-  <p:extLst>
-    <p:ext uri="{EFAFB233-063F-42B5-8137-9DF3F51BA10A}">
-      <p15:sldGuideLst xmlns:p15="http://schemas.microsoft.com/office/powerpoint/2012/main">
-        <p15:guide id="1" orient="horz" pos="2160">
-          <p15:clr>
-            <a:srgbClr val="A4A3A4"/>
-          </p15:clr>
-        </p15:guide>
-        <p15:guide id="2" pos="2880">
-          <p15:clr>
-            <a:srgbClr val="A4A3A4"/>
-          </p15:clr>
-        </p15:guide>
-      </p15:sldGuideLst>
-    </p:ext>
-  </p:extLst>
 </p:presentation>
 </file>
 
 <file path=ppt/notesMasters/notesMaster1.xml><?xml version="1.0" encoding="utf-8"?>
-<p:notesMaster xmlns:a="http://schemas.openxmlformats.org/drawingml/2006/main" xmlns:r="http://schemas.openxmlformats.org/officeDocument/2006/relationships" xmlns:p="http://schemas.openxmlformats.org/presentationml/2006/main">
+<p:notesMaster xmlns:a="http://schemas.openxmlformats.org/drawingml/2006/main" xmlns:p="http://schemas.openxmlformats.org/presentationml/2006/main" xmlns:r="http://schemas.openxmlformats.org/officeDocument/2006/relationships">
   <p:cSld>
     <p:bg>
       <p:bgRef idx="1001">
@@ -159,16 +140,241 @@
           <a:chExt cx="0" cy="0"/>
         </a:xfrm>
       </p:grpSpPr>
+      <p:sp>
+        <p:nvSpPr>
+          <p:cNvPr id="2" name="Header Placeholder 1"/>
+          <p:cNvSpPr>
+            <a:spLocks noGrp="1"/>
+          </p:cNvSpPr>
+          <p:nvPr>
+            <p:ph type="hdr" sz="quarter"/>
+          </p:nvPr>
+        </p:nvSpPr>
+        <p:spPr>
+          <a:xfrm>
+            <a:off x="0" y="0"/>
+            <a:ext cx="2971800" cy="457200"/>
+          </a:xfrm>
+          <a:prstGeom prst="rect">
+            <a:avLst/>
+          </a:prstGeom>
+        </p:spPr>
+        <p:txBody>
+          <a:bodyPr vert="horz" lIns="91440" tIns="45720" rIns="91440" bIns="45720" rtlCol="0"/>
+          <a:lstStyle>
+            <a:lvl1pPr algn="l">
+              <a:defRPr sz="1200"/>
+            </a:lvl1pPr>
+          </a:lstStyle>
+          <a:p>
+            <a:endParaRPr lang="en-US"/>
+          </a:p>
+        </p:txBody>
+      </p:sp>
+      <p:sp>
+        <p:nvSpPr>
+          <p:cNvPr id="3" name="Date Placeholder 2"/>
+          <p:cNvSpPr>
+            <a:spLocks noGrp="1"/>
+          </p:cNvSpPr>
+          <p:nvPr>
+            <p:ph type="dt" idx="1"/>
+          </p:nvPr>
+        </p:nvSpPr>
+        <p:spPr>
+          <a:xfrm>
+            <a:off x="3884613" y="0"/>
+            <a:ext cx="2971800" cy="457200"/>
+          </a:xfrm>
+          <a:prstGeom prst="rect">
+            <a:avLst/>
+          </a:prstGeom>
+        </p:spPr>
+        <p:txBody>
+          <a:bodyPr vert="horz" lIns="91440" tIns="45720" rIns="91440" bIns="45720" rtlCol="0"/>
+          <a:lstStyle>
+            <a:lvl1pPr algn="r">
+              <a:defRPr sz="1200"/>
+            </a:lvl1pPr>
+          </a:lstStyle>
+          <a:p>
+            <a:fld id="{0F89C1C7-3DCD-1040-A9CF-14679D8B5DDD}" type="datetimeFigureOut">
+              <a:rPr lang="en-US" smtClean="0"/>
+              <a:t>10/17/16</a:t>
+            </a:fld>
+            <a:endParaRPr lang="en-US"/>
+          </a:p>
+        </p:txBody>
+      </p:sp>
+      <p:sp>
+        <p:nvSpPr>
+          <p:cNvPr id="4" name="Slide Image Placeholder 3"/>
+          <p:cNvSpPr>
+            <a:spLocks noGrp="1" noRot="1" noChangeAspect="1"/>
+          </p:cNvSpPr>
+          <p:nvPr>
+            <p:ph type="sldImg" idx="2"/>
+          </p:nvPr>
+        </p:nvSpPr>
+        <p:spPr>
+          <a:xfrm>
+            <a:off x="1143000" y="685800"/>
+            <a:ext cx="4572000" cy="3429000"/>
+          </a:xfrm>
+          <a:prstGeom prst="rect">
+            <a:avLst/>
+          </a:prstGeom>
+          <a:noFill/>
+          <a:ln w="12700">
+            <a:solidFill>
+              <a:prstClr val="black"/>
+            </a:solidFill>
+          </a:ln>
+        </p:spPr>
+        <p:txBody>
+          <a:bodyPr vert="horz" lIns="91440" tIns="45720" rIns="91440" bIns="45720" rtlCol="0" anchor="ctr"/>
+          <a:lstStyle/>
+          <a:p>
+            <a:endParaRPr lang="en-US"/>
+          </a:p>
+        </p:txBody>
+      </p:sp>
+      <p:sp>
+        <p:nvSpPr>
+          <p:cNvPr id="5" name="Notes Placeholder 4"/>
+          <p:cNvSpPr>
+            <a:spLocks noGrp="1"/>
+          </p:cNvSpPr>
+          <p:nvPr>
+            <p:ph type="body" sz="quarter" idx="3"/>
+          </p:nvPr>
+        </p:nvSpPr>
+        <p:spPr>
+          <a:xfrm>
+            <a:off x="685800" y="4343400"/>
+            <a:ext cx="5486400" cy="4114800"/>
+          </a:xfrm>
+          <a:prstGeom prst="rect">
+            <a:avLst/>
+          </a:prstGeom>
+        </p:spPr>
+        <p:txBody>
+          <a:bodyPr vert="horz" lIns="91440" tIns="45720" rIns="91440" bIns="45720" rtlCol="0"/>
+          <a:lstStyle/>
+          <a:p>
+            <a:pPr lvl="0"/>
+            <a:r>
+              <a:rPr lang="en-US" smtClean="0"/>
+              <a:t>Click to edit Master text styles</a:t>
+            </a:r>
+          </a:p>
+          <a:p>
+            <a:pPr lvl="1"/>
+            <a:r>
+              <a:rPr lang="en-US" smtClean="0"/>
+              <a:t>Second level</a:t>
+            </a:r>
+          </a:p>
+          <a:p>
+            <a:pPr lvl="2"/>
+            <a:r>
+              <a:rPr lang="en-US" smtClean="0"/>
+              <a:t>Third level</a:t>
+            </a:r>
+          </a:p>
+          <a:p>
+            <a:pPr lvl="3"/>
+            <a:r>
+              <a:rPr lang="en-US" smtClean="0"/>
+              <a:t>Fourth level</a:t>
+            </a:r>
+          </a:p>
+          <a:p>
+            <a:pPr lvl="4"/>
+            <a:r>
+              <a:rPr lang="en-US" smtClean="0"/>
+              <a:t>Fifth level</a:t>
+            </a:r>
+            <a:endParaRPr lang="en-US"/>
+          </a:p>
+        </p:txBody>
+      </p:sp>
+      <p:sp>
+        <p:nvSpPr>
+          <p:cNvPr id="6" name="Footer Placeholder 5"/>
+          <p:cNvSpPr>
+            <a:spLocks noGrp="1"/>
+          </p:cNvSpPr>
+          <p:nvPr>
+            <p:ph type="ftr" sz="quarter" idx="4"/>
+          </p:nvPr>
+        </p:nvSpPr>
+        <p:spPr>
+          <a:xfrm>
+            <a:off x="0" y="8685213"/>
+            <a:ext cx="2971800" cy="457200"/>
+          </a:xfrm>
+          <a:prstGeom prst="rect">
+            <a:avLst/>
+          </a:prstGeom>
+        </p:spPr>
+        <p:txBody>
+          <a:bodyPr vert="horz" lIns="91440" tIns="45720" rIns="91440" bIns="45720" rtlCol="0" anchor="b"/>
+          <a:lstStyle>
+            <a:lvl1pPr algn="l">
+              <a:defRPr sz="1200"/>
+            </a:lvl1pPr>
+          </a:lstStyle>
+          <a:p>
+            <a:endParaRPr lang="en-US"/>
+          </a:p>
+        </p:txBody>
+      </p:sp>
+      <p:sp>
+        <p:nvSpPr>
+          <p:cNvPr id="7" name="Slide Number Placeholder 6"/>
+          <p:cNvSpPr>
+            <a:spLocks noGrp="1"/>
+          </p:cNvSpPr>
+          <p:nvPr>
+            <p:ph type="sldNum" sz="quarter" idx="5"/>
+          </p:nvPr>
+        </p:nvSpPr>
+        <p:spPr>
+          <a:xfrm>
+            <a:off x="3884613" y="8685213"/>
+            <a:ext cx="2971800" cy="457200"/>
+          </a:xfrm>
+          <a:prstGeom prst="rect">
+            <a:avLst/>
+          </a:prstGeom>
+        </p:spPr>
+        <p:txBody>
+          <a:bodyPr vert="horz" lIns="91440" tIns="45720" rIns="91440" bIns="45720" rtlCol="0" anchor="b"/>
+          <a:lstStyle>
+            <a:lvl1pPr algn="r">
+              <a:defRPr sz="1200"/>
+            </a:lvl1pPr>
+          </a:lstStyle>
+          <a:p>
+            <a:fld id="{BB5E49A5-4136-284D-997B-48E1D791AD67}" type="slidenum">
+              <a:rPr lang="en-US" smtClean="0"/>
+              <a:t>‹#›</a:t>
+            </a:fld>
+            <a:endParaRPr lang="en-US"/>
+          </a:p>
+        </p:txBody>
+      </p:sp>
     </p:spTree>
     <p:extLst>
       <p:ext uri="{BB962C8B-B14F-4D97-AF65-F5344CB8AC3E}">
-        <p14:creationId xmlns:p14="http://schemas.microsoft.com/office/powerpoint/2010/main" val="2803872382"/>
+        <p14:creationId xmlns:p14="http://schemas.microsoft.com/office/powerpoint/2010/main" val="2623252185"/>
       </p:ext>
     </p:extLst>
   </p:cSld>
   <p:clrMap bg1="lt1" tx1="dk1" bg2="lt2" tx2="dk2" accent1="accent1" accent2="accent2" accent3="accent3" accent4="accent4" accent5="accent5" accent6="accent6" hlink="hlink" folHlink="folHlink"/>
   <p:notesStyle>
-    <a:lvl1pPr marL="0" algn="l" defTabSz="914400" rtl="0" eaLnBrk="1" latinLnBrk="0" hangingPunct="1">
+    <a:lvl1pPr marL="0" algn="l" defTabSz="457200" rtl="0" eaLnBrk="1" latinLnBrk="0" hangingPunct="1">
       <a:defRPr sz="1200" kern="1200">
         <a:solidFill>
           <a:schemeClr val="tx1"/>
@@ -178,7 +384,7 @@
         <a:cs typeface="+mn-cs"/>
       </a:defRPr>
     </a:lvl1pPr>
-    <a:lvl2pPr marL="457200" algn="l" defTabSz="914400" rtl="0" eaLnBrk="1" latinLnBrk="0" hangingPunct="1">
+    <a:lvl2pPr marL="457200" algn="l" defTabSz="457200" rtl="0" eaLnBrk="1" latinLnBrk="0" hangingPunct="1">
       <a:defRPr sz="1200" kern="1200">
         <a:solidFill>
           <a:schemeClr val="tx1"/>
@@ -188,7 +394,7 @@
         <a:cs typeface="+mn-cs"/>
       </a:defRPr>
     </a:lvl2pPr>
-    <a:lvl3pPr marL="914400" algn="l" defTabSz="914400" rtl="0" eaLnBrk="1" latinLnBrk="0" hangingPunct="1">
+    <a:lvl3pPr marL="914400" algn="l" defTabSz="457200" rtl="0" eaLnBrk="1" latinLnBrk="0" hangingPunct="1">
       <a:defRPr sz="1200" kern="1200">
         <a:solidFill>
           <a:schemeClr val="tx1"/>
@@ -198,7 +404,7 @@
         <a:cs typeface="+mn-cs"/>
       </a:defRPr>
     </a:lvl3pPr>
-    <a:lvl4pPr marL="1371600" algn="l" defTabSz="914400" rtl="0" eaLnBrk="1" latinLnBrk="0" hangingPunct="1">
+    <a:lvl4pPr marL="1371600" algn="l" defTabSz="457200" rtl="0" eaLnBrk="1" latinLnBrk="0" hangingPunct="1">
       <a:defRPr sz="1200" kern="1200">
         <a:solidFill>
           <a:schemeClr val="tx1"/>
@@ -208,7 +414,7 @@
         <a:cs typeface="+mn-cs"/>
       </a:defRPr>
     </a:lvl4pPr>
-    <a:lvl5pPr marL="1828800" algn="l" defTabSz="914400" rtl="0" eaLnBrk="1" latinLnBrk="0" hangingPunct="1">
+    <a:lvl5pPr marL="1828800" algn="l" defTabSz="457200" rtl="0" eaLnBrk="1" latinLnBrk="0" hangingPunct="1">
       <a:defRPr sz="1200" kern="1200">
         <a:solidFill>
           <a:schemeClr val="tx1"/>
@@ -218,7 +424,7 @@
         <a:cs typeface="+mn-cs"/>
       </a:defRPr>
     </a:lvl5pPr>
-    <a:lvl6pPr marL="2286000" algn="l" defTabSz="914400" rtl="0" eaLnBrk="1" latinLnBrk="0" hangingPunct="1">
+    <a:lvl6pPr marL="2286000" algn="l" defTabSz="457200" rtl="0" eaLnBrk="1" latinLnBrk="0" hangingPunct="1">
       <a:defRPr sz="1200" kern="1200">
         <a:solidFill>
           <a:schemeClr val="tx1"/>
@@ -228,7 +434,7 @@
         <a:cs typeface="+mn-cs"/>
       </a:defRPr>
     </a:lvl6pPr>
-    <a:lvl7pPr marL="2743200" algn="l" defTabSz="914400" rtl="0" eaLnBrk="1" latinLnBrk="0" hangingPunct="1">
+    <a:lvl7pPr marL="2743200" algn="l" defTabSz="457200" rtl="0" eaLnBrk="1" latinLnBrk="0" hangingPunct="1">
       <a:defRPr sz="1200" kern="1200">
         <a:solidFill>
           <a:schemeClr val="tx1"/>
@@ -238,7 +444,7 @@
         <a:cs typeface="+mn-cs"/>
       </a:defRPr>
     </a:lvl7pPr>
-    <a:lvl8pPr marL="3200400" algn="l" defTabSz="914400" rtl="0" eaLnBrk="1" latinLnBrk="0" hangingPunct="1">
+    <a:lvl8pPr marL="3200400" algn="l" defTabSz="457200" rtl="0" eaLnBrk="1" latinLnBrk="0" hangingPunct="1">
       <a:defRPr sz="1200" kern="1200">
         <a:solidFill>
           <a:schemeClr val="tx1"/>
@@ -248,7 +454,7 @@
         <a:cs typeface="+mn-cs"/>
       </a:defRPr>
     </a:lvl8pPr>
-    <a:lvl9pPr marL="3657600" algn="l" defTabSz="914400" rtl="0" eaLnBrk="1" latinLnBrk="0" hangingPunct="1">
+    <a:lvl9pPr marL="3657600" algn="l" defTabSz="457200" rtl="0" eaLnBrk="1" latinLnBrk="0" hangingPunct="1">
       <a:defRPr sz="1200" kern="1200">
         <a:solidFill>
           <a:schemeClr val="tx1"/>
@@ -263,7 +469,7 @@
 </file>
 
 <file path=ppt/notesSlides/notesSlide1.xml><?xml version="1.0" encoding="utf-8"?>
-<p:notes xmlns:a="http://schemas.openxmlformats.org/drawingml/2006/main" xmlns:r="http://schemas.openxmlformats.org/officeDocument/2006/relationships" xmlns:p="http://schemas.openxmlformats.org/presentationml/2006/main">
+<p:notes xmlns:a="http://schemas.openxmlformats.org/drawingml/2006/main" xmlns:p="http://schemas.openxmlformats.org/presentationml/2006/main" xmlns:r="http://schemas.openxmlformats.org/officeDocument/2006/relationships">
   <p:cSld>
     <p:spTree>
       <p:nvGrpSpPr>
@@ -283,7 +489,7 @@
         <p:nvSpPr>
           <p:cNvPr id="2" name="Slide Image Placeholder 1"/>
           <p:cNvSpPr>
-            <a:spLocks noGrp="1" noRot="1" noChangeAspect="1"/>
+            <a:spLocks noGrp="1"/>
           </p:cNvSpPr>
           <p:nvPr>
             <p:ph type="sldImg" idx="2"/>
@@ -298,7 +504,7 @@
             <a:spLocks noGrp="1"/>
           </p:cNvSpPr>
           <p:nvPr>
-            <p:ph type="body" sz="quarter" idx="3"/>
+            <p:ph type="body" idx="3" sz="quarter"/>
           </p:nvPr>
         </p:nvSpPr>
         <p:spPr/>
@@ -319,7 +525,7 @@
             <a:spLocks noGrp="1"/>
           </p:cNvSpPr>
           <p:nvPr>
-            <p:ph type="sldNum" sz="quarter" idx="5"/>
+            <p:ph type="sldNum" idx="5" sz="quarter"/>
           </p:nvPr>
         </p:nvSpPr>
         <p:spPr/>
@@ -333,7 +539,7 @@
 </file>
 
 <file path=ppt/notesSlides/notesSlide10.xml><?xml version="1.0" encoding="utf-8"?>
-<p:notes xmlns:a="http://schemas.openxmlformats.org/drawingml/2006/main" xmlns:r="http://schemas.openxmlformats.org/officeDocument/2006/relationships" xmlns:p="http://schemas.openxmlformats.org/presentationml/2006/main">
+<p:notes xmlns:a="http://schemas.openxmlformats.org/drawingml/2006/main" xmlns:p="http://schemas.openxmlformats.org/presentationml/2006/main" xmlns:r="http://schemas.openxmlformats.org/officeDocument/2006/relationships">
   <p:cSld>
     <p:spTree>
       <p:nvGrpSpPr>
@@ -353,7 +559,7 @@
         <p:nvSpPr>
           <p:cNvPr id="2" name="Slide Image Placeholder 1"/>
           <p:cNvSpPr>
-            <a:spLocks noGrp="1" noRot="1" noChangeAspect="1"/>
+            <a:spLocks noGrp="1"/>
           </p:cNvSpPr>
           <p:nvPr>
             <p:ph type="sldImg" idx="2"/>
@@ -368,7 +574,7 @@
             <a:spLocks noGrp="1"/>
           </p:cNvSpPr>
           <p:nvPr>
-            <p:ph type="body" sz="quarter" idx="3"/>
+            <p:ph type="body" idx="3" sz="quarter"/>
           </p:nvPr>
         </p:nvSpPr>
         <p:spPr/>
@@ -389,7 +595,7 @@
             <a:spLocks noGrp="1"/>
           </p:cNvSpPr>
           <p:nvPr>
-            <p:ph type="sldNum" sz="quarter" idx="5"/>
+            <p:ph type="sldNum" idx="5" sz="quarter"/>
           </p:nvPr>
         </p:nvSpPr>
         <p:spPr/>
@@ -403,7 +609,7 @@
 </file>
 
 <file path=ppt/notesSlides/notesSlide11.xml><?xml version="1.0" encoding="utf-8"?>
-<p:notes xmlns:a="http://schemas.openxmlformats.org/drawingml/2006/main" xmlns:r="http://schemas.openxmlformats.org/officeDocument/2006/relationships" xmlns:p="http://schemas.openxmlformats.org/presentationml/2006/main">
+<p:notes xmlns:a="http://schemas.openxmlformats.org/drawingml/2006/main" xmlns:p="http://schemas.openxmlformats.org/presentationml/2006/main" xmlns:r="http://schemas.openxmlformats.org/officeDocument/2006/relationships">
   <p:cSld>
     <p:spTree>
       <p:nvGrpSpPr>
@@ -423,7 +629,7 @@
         <p:nvSpPr>
           <p:cNvPr id="2" name="Slide Image Placeholder 1"/>
           <p:cNvSpPr>
-            <a:spLocks noGrp="1" noRot="1" noChangeAspect="1"/>
+            <a:spLocks noGrp="1"/>
           </p:cNvSpPr>
           <p:nvPr>
             <p:ph type="sldImg" idx="2"/>
@@ -438,7 +644,7 @@
             <a:spLocks noGrp="1"/>
           </p:cNvSpPr>
           <p:nvPr>
-            <p:ph type="body" sz="quarter" idx="3"/>
+            <p:ph type="body" idx="3" sz="quarter"/>
           </p:nvPr>
         </p:nvSpPr>
         <p:spPr/>
@@ -447,22 +653,7 @@
           <a:lstStyle/>
           <a:p>
             <a:r>
-              <a:rPr dirty="0"/>
-              <a:t>The main limitation is dataset size. With 69 users, models are inherently </a:t>
-            </a:r>
-            <a:r>
-              <a:t>unstable</a:t>
-            </a:r>
-            <a:r>
-              <a:rPr lang="en-US"/>
-              <a:t>. </a:t>
-            </a:r>
-            <a:r>
-              <a:t>A </a:t>
-            </a:r>
-            <a:r>
-              <a:rPr dirty="0"/>
-              <a:t>temporal split approach would also improve reliability by simulating real-world deployment.</a:t>
+              <a:t>The main limitation is dataset size. With 69 users, models are inherently unstable. The proxy demographics add features but may introduce noise. We recommend expanding to 200+ users with complete real demographic data. A temporal split approach would also improve reliability by simulating real-world deployment.</a:t>
             </a:r>
           </a:p>
         </p:txBody>
@@ -474,7 +665,7 @@
             <a:spLocks noGrp="1"/>
           </p:cNvSpPr>
           <p:nvPr>
-            <p:ph type="sldNum" sz="quarter" idx="5"/>
+            <p:ph type="sldNum" idx="5" sz="quarter"/>
           </p:nvPr>
         </p:nvSpPr>
         <p:spPr/>
@@ -488,7 +679,7 @@
 </file>
 
 <file path=ppt/notesSlides/notesSlide12.xml><?xml version="1.0" encoding="utf-8"?>
-<p:notes xmlns:a="http://schemas.openxmlformats.org/drawingml/2006/main" xmlns:r="http://schemas.openxmlformats.org/officeDocument/2006/relationships" xmlns:p="http://schemas.openxmlformats.org/presentationml/2006/main">
+<p:notes xmlns:a="http://schemas.openxmlformats.org/drawingml/2006/main" xmlns:p="http://schemas.openxmlformats.org/presentationml/2006/main" xmlns:r="http://schemas.openxmlformats.org/officeDocument/2006/relationships">
   <p:cSld>
     <p:spTree>
       <p:nvGrpSpPr>
@@ -508,7 +699,7 @@
         <p:nvSpPr>
           <p:cNvPr id="2" name="Slide Image Placeholder 1"/>
           <p:cNvSpPr>
-            <a:spLocks noGrp="1" noRot="1" noChangeAspect="1"/>
+            <a:spLocks noGrp="1"/>
           </p:cNvSpPr>
           <p:nvPr>
             <p:ph type="sldImg" idx="2"/>
@@ -523,7 +714,7 @@
             <a:spLocks noGrp="1"/>
           </p:cNvSpPr>
           <p:nvPr>
-            <p:ph type="body" sz="quarter" idx="3"/>
+            <p:ph type="body" idx="3" sz="quarter"/>
           </p:nvPr>
         </p:nvSpPr>
         <p:spPr/>
@@ -532,7 +723,7 @@
           <a:lstStyle/>
           <a:p>
             <a:r>
-              <a:t>In conclusion, we demonstrated that mobile money transaction behavior alone carries genuine predictive signal for user activity classification. XGBoost achieved an F1 of 0.57, well above baselines. Demographic integration showed mixed results due to mostly simulated data, but profession and education provided secondary signals. The three user profiles we identified have direct business applications. Thank you.</a:t>
+              <a:t>In conclusion, we demonstrated that mobile money transaction behavior alone carries genuine predictive signal for user activity classification. Random Forest on behavioral features achieved an F1 of 0.55, well above baselines. Demographic integration showed mixed results due to limited real questionnaire coverage, but profession and education provided secondary signals. The three user profiles we identified have direct business applications. Thank you.</a:t>
             </a:r>
           </a:p>
         </p:txBody>
@@ -544,7 +735,7 @@
             <a:spLocks noGrp="1"/>
           </p:cNvSpPr>
           <p:nvPr>
-            <p:ph type="sldNum" sz="quarter" idx="5"/>
+            <p:ph type="sldNum" idx="5" sz="quarter"/>
           </p:nvPr>
         </p:nvSpPr>
         <p:spPr/>
@@ -558,7 +749,7 @@
 </file>
 
 <file path=ppt/notesSlides/notesSlide2.xml><?xml version="1.0" encoding="utf-8"?>
-<p:notes xmlns:a="http://schemas.openxmlformats.org/drawingml/2006/main" xmlns:r="http://schemas.openxmlformats.org/officeDocument/2006/relationships" xmlns:p="http://schemas.openxmlformats.org/presentationml/2006/main">
+<p:notes xmlns:a="http://schemas.openxmlformats.org/drawingml/2006/main" xmlns:p="http://schemas.openxmlformats.org/presentationml/2006/main" xmlns:r="http://schemas.openxmlformats.org/officeDocument/2006/relationships">
   <p:cSld>
     <p:spTree>
       <p:nvGrpSpPr>
@@ -578,7 +769,7 @@
         <p:nvSpPr>
           <p:cNvPr id="2" name="Slide Image Placeholder 1"/>
           <p:cNvSpPr>
-            <a:spLocks noGrp="1" noRot="1" noChangeAspect="1"/>
+            <a:spLocks noGrp="1"/>
           </p:cNvSpPr>
           <p:nvPr>
             <p:ph type="sldImg" idx="2"/>
@@ -593,7 +784,7 @@
             <a:spLocks noGrp="1"/>
           </p:cNvSpPr>
           <p:nvPr>
-            <p:ph type="body" sz="quarter" idx="3"/>
+            <p:ph type="body" idx="3" sz="quarter"/>
           </p:nvPr>
         </p:nvSpPr>
         <p:spPr/>
@@ -614,7 +805,7 @@
             <a:spLocks noGrp="1"/>
           </p:cNvSpPr>
           <p:nvPr>
-            <p:ph type="sldNum" sz="quarter" idx="5"/>
+            <p:ph type="sldNum" idx="5" sz="quarter"/>
           </p:nvPr>
         </p:nvSpPr>
         <p:spPr/>
@@ -628,7 +819,7 @@
 </file>
 
 <file path=ppt/notesSlides/notesSlide3.xml><?xml version="1.0" encoding="utf-8"?>
-<p:notes xmlns:a="http://schemas.openxmlformats.org/drawingml/2006/main" xmlns:r="http://schemas.openxmlformats.org/officeDocument/2006/relationships" xmlns:p="http://schemas.openxmlformats.org/presentationml/2006/main">
+<p:notes xmlns:a="http://schemas.openxmlformats.org/drawingml/2006/main" xmlns:p="http://schemas.openxmlformats.org/presentationml/2006/main" xmlns:r="http://schemas.openxmlformats.org/officeDocument/2006/relationships">
   <p:cSld>
     <p:spTree>
       <p:nvGrpSpPr>
@@ -648,7 +839,7 @@
         <p:nvSpPr>
           <p:cNvPr id="2" name="Slide Image Placeholder 1"/>
           <p:cNvSpPr>
-            <a:spLocks noGrp="1" noRot="1" noChangeAspect="1"/>
+            <a:spLocks noGrp="1"/>
           </p:cNvSpPr>
           <p:nvPr>
             <p:ph type="sldImg" idx="2"/>
@@ -663,7 +854,7 @@
             <a:spLocks noGrp="1"/>
           </p:cNvSpPr>
           <p:nvPr>
-            <p:ph type="body" sz="quarter" idx="3"/>
+            <p:ph type="body" idx="3" sz="quarter"/>
           </p:nvPr>
         </p:nvSpPr>
         <p:spPr/>
@@ -672,7 +863,7 @@
           <a:lstStyle/>
           <a:p>
             <a:r>
-              <a:t>Our behavioral data comes from SMS transaction messages exported by 69 users. We augmented this with a demographic questionnaire completed by 10 users. For the remaining 59, we simulated plausible demographics based on the 10 real responses and Cameroon population statistics. This is clearly documented as simulated data. The behavioral features describe HOW users transact, while demographic features describe WHO they are.</a:t>
+              <a:t>Our behavioral data comes from SMS transaction messages exported by 69 users. We augmented this with a demographic questionnaire completed by 10 users. For the remaining 59, we generated proxy demographics based on the 10 real responses and Cameroon population statistics. This is clearly documented as proxy data. The behavioral features describe HOW users transact, while demographic features describe WHO they are.</a:t>
             </a:r>
           </a:p>
         </p:txBody>
@@ -684,7 +875,7 @@
             <a:spLocks noGrp="1"/>
           </p:cNvSpPr>
           <p:nvPr>
-            <p:ph type="sldNum" sz="quarter" idx="5"/>
+            <p:ph type="sldNum" idx="5" sz="quarter"/>
           </p:nvPr>
         </p:nvSpPr>
         <p:spPr/>
@@ -698,7 +889,7 @@
 </file>
 
 <file path=ppt/notesSlides/notesSlide4.xml><?xml version="1.0" encoding="utf-8"?>
-<p:notes xmlns:a="http://schemas.openxmlformats.org/drawingml/2006/main" xmlns:r="http://schemas.openxmlformats.org/officeDocument/2006/relationships" xmlns:p="http://schemas.openxmlformats.org/presentationml/2006/main">
+<p:notes xmlns:a="http://schemas.openxmlformats.org/drawingml/2006/main" xmlns:p="http://schemas.openxmlformats.org/presentationml/2006/main" xmlns:r="http://schemas.openxmlformats.org/officeDocument/2006/relationships">
   <p:cSld>
     <p:spTree>
       <p:nvGrpSpPr>
@@ -718,7 +909,7 @@
         <p:nvSpPr>
           <p:cNvPr id="2" name="Slide Image Placeholder 1"/>
           <p:cNvSpPr>
-            <a:spLocks noGrp="1" noRot="1" noChangeAspect="1"/>
+            <a:spLocks noGrp="1"/>
           </p:cNvSpPr>
           <p:nvPr>
             <p:ph type="sldImg" idx="2"/>
@@ -733,7 +924,7 @@
             <a:spLocks noGrp="1"/>
           </p:cNvSpPr>
           <p:nvPr>
-            <p:ph type="body" sz="quarter" idx="3"/>
+            <p:ph type="body" idx="3" sz="quarter"/>
           </p:nvPr>
         </p:nvSpPr>
         <p:spPr/>
@@ -754,7 +945,7 @@
             <a:spLocks noGrp="1"/>
           </p:cNvSpPr>
           <p:nvPr>
-            <p:ph type="sldNum" sz="quarter" idx="5"/>
+            <p:ph type="sldNum" idx="5" sz="quarter"/>
           </p:nvPr>
         </p:nvSpPr>
         <p:spPr/>
@@ -768,7 +959,7 @@
 </file>
 
 <file path=ppt/notesSlides/notesSlide5.xml><?xml version="1.0" encoding="utf-8"?>
-<p:notes xmlns:a="http://schemas.openxmlformats.org/drawingml/2006/main" xmlns:r="http://schemas.openxmlformats.org/officeDocument/2006/relationships" xmlns:p="http://schemas.openxmlformats.org/presentationml/2006/main">
+<p:notes xmlns:a="http://schemas.openxmlformats.org/drawingml/2006/main" xmlns:p="http://schemas.openxmlformats.org/presentationml/2006/main" xmlns:r="http://schemas.openxmlformats.org/officeDocument/2006/relationships">
   <p:cSld>
     <p:spTree>
       <p:nvGrpSpPr>
@@ -788,7 +979,7 @@
         <p:nvSpPr>
           <p:cNvPr id="2" name="Slide Image Placeholder 1"/>
           <p:cNvSpPr>
-            <a:spLocks noGrp="1" noRot="1" noChangeAspect="1"/>
+            <a:spLocks noGrp="1"/>
           </p:cNvSpPr>
           <p:nvPr>
             <p:ph type="sldImg" idx="2"/>
@@ -803,7 +994,7 @@
             <a:spLocks noGrp="1"/>
           </p:cNvSpPr>
           <p:nvPr>
-            <p:ph type="body" sz="quarter" idx="3"/>
+            <p:ph type="body" idx="3" sz="quarter"/>
           </p:nvPr>
         </p:nvSpPr>
         <p:spPr/>
@@ -824,7 +1015,7 @@
             <a:spLocks noGrp="1"/>
           </p:cNvSpPr>
           <p:nvPr>
-            <p:ph type="sldNum" sz="quarter" idx="5"/>
+            <p:ph type="sldNum" idx="5" sz="quarter"/>
           </p:nvPr>
         </p:nvSpPr>
         <p:spPr/>
@@ -838,7 +1029,7 @@
 </file>
 
 <file path=ppt/notesSlides/notesSlide6.xml><?xml version="1.0" encoding="utf-8"?>
-<p:notes xmlns:a="http://schemas.openxmlformats.org/drawingml/2006/main" xmlns:r="http://schemas.openxmlformats.org/officeDocument/2006/relationships" xmlns:p="http://schemas.openxmlformats.org/presentationml/2006/main">
+<p:notes xmlns:a="http://schemas.openxmlformats.org/drawingml/2006/main" xmlns:p="http://schemas.openxmlformats.org/presentationml/2006/main" xmlns:r="http://schemas.openxmlformats.org/officeDocument/2006/relationships">
   <p:cSld>
     <p:spTree>
       <p:nvGrpSpPr>
@@ -858,7 +1049,7 @@
         <p:nvSpPr>
           <p:cNvPr id="2" name="Slide Image Placeholder 1"/>
           <p:cNvSpPr>
-            <a:spLocks noGrp="1" noRot="1" noChangeAspect="1"/>
+            <a:spLocks noGrp="1"/>
           </p:cNvSpPr>
           <p:nvPr>
             <p:ph type="sldImg" idx="2"/>
@@ -873,7 +1064,7 @@
             <a:spLocks noGrp="1"/>
           </p:cNvSpPr>
           <p:nvPr>
-            <p:ph type="body" sz="quarter" idx="3"/>
+            <p:ph type="body" idx="3" sz="quarter"/>
           </p:nvPr>
         </p:nvSpPr>
         <p:spPr/>
@@ -894,7 +1085,7 @@
             <a:spLocks noGrp="1"/>
           </p:cNvSpPr>
           <p:nvPr>
-            <p:ph type="sldNum" sz="quarter" idx="5"/>
+            <p:ph type="sldNum" idx="5" sz="quarter"/>
           </p:nvPr>
         </p:nvSpPr>
         <p:spPr/>
@@ -908,7 +1099,7 @@
 </file>
 
 <file path=ppt/notesSlides/notesSlide7.xml><?xml version="1.0" encoding="utf-8"?>
-<p:notes xmlns:a="http://schemas.openxmlformats.org/drawingml/2006/main" xmlns:r="http://schemas.openxmlformats.org/officeDocument/2006/relationships" xmlns:p="http://schemas.openxmlformats.org/presentationml/2006/main">
+<p:notes xmlns:a="http://schemas.openxmlformats.org/drawingml/2006/main" xmlns:p="http://schemas.openxmlformats.org/presentationml/2006/main" xmlns:r="http://schemas.openxmlformats.org/officeDocument/2006/relationships">
   <p:cSld>
     <p:spTree>
       <p:nvGrpSpPr>
@@ -928,7 +1119,7 @@
         <p:nvSpPr>
           <p:cNvPr id="2" name="Slide Image Placeholder 1"/>
           <p:cNvSpPr>
-            <a:spLocks noGrp="1" noRot="1" noChangeAspect="1"/>
+            <a:spLocks noGrp="1"/>
           </p:cNvSpPr>
           <p:nvPr>
             <p:ph type="sldImg" idx="2"/>
@@ -943,7 +1134,7 @@
             <a:spLocks noGrp="1"/>
           </p:cNvSpPr>
           <p:nvPr>
-            <p:ph type="body" sz="quarter" idx="3"/>
+            <p:ph type="body" idx="3" sz="quarter"/>
           </p:nvPr>
         </p:nvSpPr>
         <p:spPr/>
@@ -952,7 +1143,7 @@
           <a:lstStyle/>
           <a:p>
             <a:r>
-              <a:t>XGBoost with behavioral features alone achieved the highest F1 macro of 0.57. When we added demographics, Random Forest improved but XGBoost slightly decreased. This is because 59 of 69 demographics are simulated, adding noise. With real demographic data, we would expect more consistent improvement. All models beat baselines.</a:t>
+              <a:t>Behavioral-only Random Forest achieved the highest F1 macro of 0.55 on this split. When we added demographics, Logistic Regression improved, but the tree-based models declined. This reflects limited real questionnaire coverage. With more real demographic data, we would expect more stable demographic effects. All models beat baselines.</a:t>
             </a:r>
           </a:p>
         </p:txBody>
@@ -964,7 +1155,7 @@
             <a:spLocks noGrp="1"/>
           </p:cNvSpPr>
           <p:nvPr>
-            <p:ph type="sldNum" sz="quarter" idx="5"/>
+            <p:ph type="sldNum" idx="5" sz="quarter"/>
           </p:nvPr>
         </p:nvSpPr>
         <p:spPr/>
@@ -978,7 +1169,7 @@
 </file>
 
 <file path=ppt/notesSlides/notesSlide8.xml><?xml version="1.0" encoding="utf-8"?>
-<p:notes xmlns:a="http://schemas.openxmlformats.org/drawingml/2006/main" xmlns:r="http://schemas.openxmlformats.org/officeDocument/2006/relationships" xmlns:p="http://schemas.openxmlformats.org/presentationml/2006/main">
+<p:notes xmlns:a="http://schemas.openxmlformats.org/drawingml/2006/main" xmlns:p="http://schemas.openxmlformats.org/presentationml/2006/main" xmlns:r="http://schemas.openxmlformats.org/officeDocument/2006/relationships">
   <p:cSld>
     <p:spTree>
       <p:nvGrpSpPr>
@@ -998,7 +1189,7 @@
         <p:nvSpPr>
           <p:cNvPr id="2" name="Slide Image Placeholder 1"/>
           <p:cNvSpPr>
-            <a:spLocks noGrp="1" noRot="1" noChangeAspect="1"/>
+            <a:spLocks noGrp="1"/>
           </p:cNvSpPr>
           <p:nvPr>
             <p:ph type="sldImg" idx="2"/>
@@ -1013,7 +1204,7 @@
             <a:spLocks noGrp="1"/>
           </p:cNvSpPr>
           <p:nvPr>
-            <p:ph type="body" sz="quarter" idx="3"/>
+            <p:ph type="body" idx="3" sz="quarter"/>
           </p:nvPr>
         </p:nvSpPr>
         <p:spPr/>
@@ -1034,7 +1225,7 @@
             <a:spLocks noGrp="1"/>
           </p:cNvSpPr>
           <p:nvPr>
-            <p:ph type="sldNum" sz="quarter" idx="5"/>
+            <p:ph type="sldNum" idx="5" sz="quarter"/>
           </p:nvPr>
         </p:nvSpPr>
         <p:spPr/>
@@ -1048,7 +1239,7 @@
 </file>
 
 <file path=ppt/notesSlides/notesSlide9.xml><?xml version="1.0" encoding="utf-8"?>
-<p:notes xmlns:a="http://schemas.openxmlformats.org/drawingml/2006/main" xmlns:r="http://schemas.openxmlformats.org/officeDocument/2006/relationships" xmlns:p="http://schemas.openxmlformats.org/presentationml/2006/main">
+<p:notes xmlns:a="http://schemas.openxmlformats.org/drawingml/2006/main" xmlns:p="http://schemas.openxmlformats.org/presentationml/2006/main" xmlns:r="http://schemas.openxmlformats.org/officeDocument/2006/relationships">
   <p:cSld>
     <p:spTree>
       <p:nvGrpSpPr>
@@ -1068,7 +1259,7 @@
         <p:nvSpPr>
           <p:cNvPr id="2" name="Slide Image Placeholder 1"/>
           <p:cNvSpPr>
-            <a:spLocks noGrp="1" noRot="1" noChangeAspect="1"/>
+            <a:spLocks noGrp="1"/>
           </p:cNvSpPr>
           <p:nvPr>
             <p:ph type="sldImg" idx="2"/>
@@ -1083,7 +1274,7 @@
             <a:spLocks noGrp="1"/>
           </p:cNvSpPr>
           <p:nvPr>
-            <p:ph type="body" sz="quarter" idx="3"/>
+            <p:ph type="body" idx="3" sz="quarter"/>
           </p:nvPr>
         </p:nvSpPr>
         <p:spPr/>
@@ -1104,7 +1295,7 @@
             <a:spLocks noGrp="1"/>
           </p:cNvSpPr>
           <p:nvPr>
-            <p:ph type="sldNum" sz="quarter" idx="5"/>
+            <p:ph type="sldNum" idx="5" sz="quarter"/>
           </p:nvPr>
         </p:nvSpPr>
         <p:spPr/>
@@ -1155,9 +1346,10 @@
           <a:lstStyle/>
           <a:p>
             <a:r>
-              <a:rPr lang="en-US"/>
+              <a:rPr lang="en-US" smtClean="0"/>
               <a:t>Click to edit Master title style</a:t>
             </a:r>
+            <a:endParaRPr lang="en-US"/>
           </a:p>
         </p:txBody>
       </p:sp>
@@ -1273,9 +1465,10 @@
           </a:lstStyle>
           <a:p>
             <a:r>
-              <a:rPr lang="en-US"/>
+              <a:rPr lang="en-US" smtClean="0"/>
               <a:t>Click to edit Master subtitle style</a:t>
             </a:r>
+            <a:endParaRPr lang="en-US"/>
           </a:p>
         </p:txBody>
       </p:sp>
@@ -1296,7 +1489,7 @@
           <a:p>
             <a:fld id="{5BCAD085-E8A6-8845-BD4E-CB4CCA059FC4}" type="datetimeFigureOut">
               <a:rPr lang="en-US" smtClean="0"/>
-              <a:t>5/3/2026</a:t>
+              <a:t>1/27/13</a:t>
             </a:fld>
             <a:endParaRPr lang="en-US"/>
           </a:p>
@@ -1390,9 +1583,10 @@
           <a:lstStyle/>
           <a:p>
             <a:r>
-              <a:rPr lang="en-US"/>
+              <a:rPr lang="en-US" smtClean="0"/>
               <a:t>Click to edit Master title style</a:t>
             </a:r>
+            <a:endParaRPr lang="en-US"/>
           </a:p>
         </p:txBody>
       </p:sp>
@@ -1413,37 +1607,38 @@
           <a:p>
             <a:pPr lvl="0"/>
             <a:r>
-              <a:rPr lang="en-US"/>
+              <a:rPr lang="en-US" smtClean="0"/>
               <a:t>Click to edit Master text styles</a:t>
             </a:r>
           </a:p>
           <a:p>
             <a:pPr lvl="1"/>
             <a:r>
-              <a:rPr lang="en-US"/>
+              <a:rPr lang="en-US" smtClean="0"/>
               <a:t>Second level</a:t>
             </a:r>
           </a:p>
           <a:p>
             <a:pPr lvl="2"/>
             <a:r>
-              <a:rPr lang="en-US"/>
+              <a:rPr lang="en-US" smtClean="0"/>
               <a:t>Third level</a:t>
             </a:r>
           </a:p>
           <a:p>
             <a:pPr lvl="3"/>
             <a:r>
-              <a:rPr lang="en-US"/>
+              <a:rPr lang="en-US" smtClean="0"/>
               <a:t>Fourth level</a:t>
             </a:r>
           </a:p>
           <a:p>
             <a:pPr lvl="4"/>
             <a:r>
-              <a:rPr lang="en-US"/>
+              <a:rPr lang="en-US" smtClean="0"/>
               <a:t>Fifth level</a:t>
             </a:r>
+            <a:endParaRPr lang="en-US"/>
           </a:p>
         </p:txBody>
       </p:sp>
@@ -1464,7 +1659,7 @@
           <a:p>
             <a:fld id="{5BCAD085-E8A6-8845-BD4E-CB4CCA059FC4}" type="datetimeFigureOut">
               <a:rPr lang="en-US" smtClean="0"/>
-              <a:t>5/3/2026</a:t>
+              <a:t>1/27/13</a:t>
             </a:fld>
             <a:endParaRPr lang="en-US"/>
           </a:p>
@@ -1563,9 +1758,10 @@
           <a:lstStyle/>
           <a:p>
             <a:r>
-              <a:rPr lang="en-US"/>
+              <a:rPr lang="en-US" smtClean="0"/>
               <a:t>Click to edit Master title style</a:t>
             </a:r>
+            <a:endParaRPr lang="en-US"/>
           </a:p>
         </p:txBody>
       </p:sp>
@@ -1591,37 +1787,38 @@
           <a:p>
             <a:pPr lvl="0"/>
             <a:r>
-              <a:rPr lang="en-US"/>
+              <a:rPr lang="en-US" smtClean="0"/>
               <a:t>Click to edit Master text styles</a:t>
             </a:r>
           </a:p>
           <a:p>
             <a:pPr lvl="1"/>
             <a:r>
-              <a:rPr lang="en-US"/>
+              <a:rPr lang="en-US" smtClean="0"/>
               <a:t>Second level</a:t>
             </a:r>
           </a:p>
           <a:p>
             <a:pPr lvl="2"/>
             <a:r>
-              <a:rPr lang="en-US"/>
+              <a:rPr lang="en-US" smtClean="0"/>
               <a:t>Third level</a:t>
             </a:r>
           </a:p>
           <a:p>
             <a:pPr lvl="3"/>
             <a:r>
-              <a:rPr lang="en-US"/>
+              <a:rPr lang="en-US" smtClean="0"/>
               <a:t>Fourth level</a:t>
             </a:r>
           </a:p>
           <a:p>
             <a:pPr lvl="4"/>
             <a:r>
-              <a:rPr lang="en-US"/>
+              <a:rPr lang="en-US" smtClean="0"/>
               <a:t>Fifth level</a:t>
             </a:r>
+            <a:endParaRPr lang="en-US"/>
           </a:p>
         </p:txBody>
       </p:sp>
@@ -1642,7 +1839,7 @@
           <a:p>
             <a:fld id="{5BCAD085-E8A6-8845-BD4E-CB4CCA059FC4}" type="datetimeFigureOut">
               <a:rPr lang="en-US" smtClean="0"/>
-              <a:t>5/3/2026</a:t>
+              <a:t>1/27/13</a:t>
             </a:fld>
             <a:endParaRPr lang="en-US"/>
           </a:p>
@@ -1736,9 +1933,10 @@
           <a:lstStyle/>
           <a:p>
             <a:r>
-              <a:rPr lang="en-US"/>
+              <a:rPr lang="en-US" smtClean="0"/>
               <a:t>Click to edit Master title style</a:t>
             </a:r>
+            <a:endParaRPr lang="en-US"/>
           </a:p>
         </p:txBody>
       </p:sp>
@@ -1759,37 +1957,38 @@
           <a:p>
             <a:pPr lvl="0"/>
             <a:r>
-              <a:rPr lang="en-US"/>
+              <a:rPr lang="en-US" smtClean="0"/>
               <a:t>Click to edit Master text styles</a:t>
             </a:r>
           </a:p>
           <a:p>
             <a:pPr lvl="1"/>
             <a:r>
-              <a:rPr lang="en-US"/>
+              <a:rPr lang="en-US" smtClean="0"/>
               <a:t>Second level</a:t>
             </a:r>
           </a:p>
           <a:p>
             <a:pPr lvl="2"/>
             <a:r>
-              <a:rPr lang="en-US"/>
+              <a:rPr lang="en-US" smtClean="0"/>
               <a:t>Third level</a:t>
             </a:r>
           </a:p>
           <a:p>
             <a:pPr lvl="3"/>
             <a:r>
-              <a:rPr lang="en-US"/>
+              <a:rPr lang="en-US" smtClean="0"/>
               <a:t>Fourth level</a:t>
             </a:r>
           </a:p>
           <a:p>
             <a:pPr lvl="4"/>
             <a:r>
-              <a:rPr lang="en-US"/>
+              <a:rPr lang="en-US" smtClean="0"/>
               <a:t>Fifth level</a:t>
             </a:r>
+            <a:endParaRPr lang="en-US"/>
           </a:p>
         </p:txBody>
       </p:sp>
@@ -1810,7 +2009,7 @@
           <a:p>
             <a:fld id="{5BCAD085-E8A6-8845-BD4E-CB4CCA059FC4}" type="datetimeFigureOut">
               <a:rPr lang="en-US" smtClean="0"/>
-              <a:t>5/3/2026</a:t>
+              <a:t>1/27/13</a:t>
             </a:fld>
             <a:endParaRPr lang="en-US"/>
           </a:p>
@@ -1913,9 +2112,10 @@
           </a:lstStyle>
           <a:p>
             <a:r>
-              <a:rPr lang="en-US"/>
+              <a:rPr lang="en-US" smtClean="0"/>
               <a:t>Click to edit Master title style</a:t>
             </a:r>
+            <a:endParaRPr lang="en-US"/>
           </a:p>
         </p:txBody>
       </p:sp>
@@ -2032,7 +2232,7 @@
           <a:p>
             <a:pPr lvl="0"/>
             <a:r>
-              <a:rPr lang="en-US"/>
+              <a:rPr lang="en-US" smtClean="0"/>
               <a:t>Click to edit Master text styles</a:t>
             </a:r>
           </a:p>
@@ -2055,7 +2255,7 @@
           <a:p>
             <a:fld id="{5BCAD085-E8A6-8845-BD4E-CB4CCA059FC4}" type="datetimeFigureOut">
               <a:rPr lang="en-US" smtClean="0"/>
-              <a:t>5/3/2026</a:t>
+              <a:t>1/27/13</a:t>
             </a:fld>
             <a:endParaRPr lang="en-US"/>
           </a:p>
@@ -2149,9 +2349,10 @@
           <a:lstStyle/>
           <a:p>
             <a:r>
-              <a:rPr lang="en-US"/>
+              <a:rPr lang="en-US" smtClean="0"/>
               <a:t>Click to edit Master title style</a:t>
             </a:r>
+            <a:endParaRPr lang="en-US"/>
           </a:p>
         </p:txBody>
       </p:sp>
@@ -2205,37 +2406,38 @@
           <a:p>
             <a:pPr lvl="0"/>
             <a:r>
-              <a:rPr lang="en-US"/>
+              <a:rPr lang="en-US" smtClean="0"/>
               <a:t>Click to edit Master text styles</a:t>
             </a:r>
           </a:p>
           <a:p>
             <a:pPr lvl="1"/>
             <a:r>
-              <a:rPr lang="en-US"/>
+              <a:rPr lang="en-US" smtClean="0"/>
               <a:t>Second level</a:t>
             </a:r>
           </a:p>
           <a:p>
             <a:pPr lvl="2"/>
             <a:r>
-              <a:rPr lang="en-US"/>
+              <a:rPr lang="en-US" smtClean="0"/>
               <a:t>Third level</a:t>
             </a:r>
           </a:p>
           <a:p>
             <a:pPr lvl="3"/>
             <a:r>
-              <a:rPr lang="en-US"/>
+              <a:rPr lang="en-US" smtClean="0"/>
               <a:t>Fourth level</a:t>
             </a:r>
           </a:p>
           <a:p>
             <a:pPr lvl="4"/>
             <a:r>
-              <a:rPr lang="en-US"/>
+              <a:rPr lang="en-US" smtClean="0"/>
               <a:t>Fifth level</a:t>
             </a:r>
+            <a:endParaRPr lang="en-US"/>
           </a:p>
         </p:txBody>
       </p:sp>
@@ -2289,37 +2491,38 @@
           <a:p>
             <a:pPr lvl="0"/>
             <a:r>
-              <a:rPr lang="en-US"/>
+              <a:rPr lang="en-US" smtClean="0"/>
               <a:t>Click to edit Master text styles</a:t>
             </a:r>
           </a:p>
           <a:p>
             <a:pPr lvl="1"/>
             <a:r>
-              <a:rPr lang="en-US"/>
+              <a:rPr lang="en-US" smtClean="0"/>
               <a:t>Second level</a:t>
             </a:r>
           </a:p>
           <a:p>
             <a:pPr lvl="2"/>
             <a:r>
-              <a:rPr lang="en-US"/>
+              <a:rPr lang="en-US" smtClean="0"/>
               <a:t>Third level</a:t>
             </a:r>
           </a:p>
           <a:p>
             <a:pPr lvl="3"/>
             <a:r>
-              <a:rPr lang="en-US"/>
+              <a:rPr lang="en-US" smtClean="0"/>
               <a:t>Fourth level</a:t>
             </a:r>
           </a:p>
           <a:p>
             <a:pPr lvl="4"/>
             <a:r>
-              <a:rPr lang="en-US"/>
+              <a:rPr lang="en-US" smtClean="0"/>
               <a:t>Fifth level</a:t>
             </a:r>
+            <a:endParaRPr lang="en-US"/>
           </a:p>
         </p:txBody>
       </p:sp>
@@ -2340,7 +2543,7 @@
           <a:p>
             <a:fld id="{5BCAD085-E8A6-8845-BD4E-CB4CCA059FC4}" type="datetimeFigureOut">
               <a:rPr lang="en-US" smtClean="0"/>
-              <a:t>5/3/2026</a:t>
+              <a:t>1/27/13</a:t>
             </a:fld>
             <a:endParaRPr lang="en-US"/>
           </a:p>
@@ -2438,9 +2641,10 @@
           </a:lstStyle>
           <a:p>
             <a:r>
-              <a:rPr lang="en-US"/>
+              <a:rPr lang="en-US" smtClean="0"/>
               <a:t>Click to edit Master title style</a:t>
             </a:r>
+            <a:endParaRPr lang="en-US"/>
           </a:p>
         </p:txBody>
       </p:sp>
@@ -2503,7 +2707,7 @@
           <a:p>
             <a:pPr lvl="0"/>
             <a:r>
-              <a:rPr lang="en-US"/>
+              <a:rPr lang="en-US" smtClean="0"/>
               <a:t>Click to edit Master text styles</a:t>
             </a:r>
           </a:p>
@@ -2559,37 +2763,38 @@
           <a:p>
             <a:pPr lvl="0"/>
             <a:r>
-              <a:rPr lang="en-US"/>
+              <a:rPr lang="en-US" smtClean="0"/>
               <a:t>Click to edit Master text styles</a:t>
             </a:r>
           </a:p>
           <a:p>
             <a:pPr lvl="1"/>
             <a:r>
-              <a:rPr lang="en-US"/>
+              <a:rPr lang="en-US" smtClean="0"/>
               <a:t>Second level</a:t>
             </a:r>
           </a:p>
           <a:p>
             <a:pPr lvl="2"/>
             <a:r>
-              <a:rPr lang="en-US"/>
+              <a:rPr lang="en-US" smtClean="0"/>
               <a:t>Third level</a:t>
             </a:r>
           </a:p>
           <a:p>
             <a:pPr lvl="3"/>
             <a:r>
-              <a:rPr lang="en-US"/>
+              <a:rPr lang="en-US" smtClean="0"/>
               <a:t>Fourth level</a:t>
             </a:r>
           </a:p>
           <a:p>
             <a:pPr lvl="4"/>
             <a:r>
-              <a:rPr lang="en-US"/>
+              <a:rPr lang="en-US" smtClean="0"/>
               <a:t>Fifth level</a:t>
             </a:r>
+            <a:endParaRPr lang="en-US"/>
           </a:p>
         </p:txBody>
       </p:sp>
@@ -2652,7 +2857,7 @@
           <a:p>
             <a:pPr lvl="0"/>
             <a:r>
-              <a:rPr lang="en-US"/>
+              <a:rPr lang="en-US" smtClean="0"/>
               <a:t>Click to edit Master text styles</a:t>
             </a:r>
           </a:p>
@@ -2708,37 +2913,38 @@
           <a:p>
             <a:pPr lvl="0"/>
             <a:r>
-              <a:rPr lang="en-US"/>
+              <a:rPr lang="en-US" smtClean="0"/>
               <a:t>Click to edit Master text styles</a:t>
             </a:r>
           </a:p>
           <a:p>
             <a:pPr lvl="1"/>
             <a:r>
-              <a:rPr lang="en-US"/>
+              <a:rPr lang="en-US" smtClean="0"/>
               <a:t>Second level</a:t>
             </a:r>
           </a:p>
           <a:p>
             <a:pPr lvl="2"/>
             <a:r>
-              <a:rPr lang="en-US"/>
+              <a:rPr lang="en-US" smtClean="0"/>
               <a:t>Third level</a:t>
             </a:r>
           </a:p>
           <a:p>
             <a:pPr lvl="3"/>
             <a:r>
-              <a:rPr lang="en-US"/>
+              <a:rPr lang="en-US" smtClean="0"/>
               <a:t>Fourth level</a:t>
             </a:r>
           </a:p>
           <a:p>
             <a:pPr lvl="4"/>
             <a:r>
-              <a:rPr lang="en-US"/>
+              <a:rPr lang="en-US" smtClean="0"/>
               <a:t>Fifth level</a:t>
             </a:r>
+            <a:endParaRPr lang="en-US"/>
           </a:p>
         </p:txBody>
       </p:sp>
@@ -2759,7 +2965,7 @@
           <a:p>
             <a:fld id="{5BCAD085-E8A6-8845-BD4E-CB4CCA059FC4}" type="datetimeFigureOut">
               <a:rPr lang="en-US" smtClean="0"/>
-              <a:t>5/3/2026</a:t>
+              <a:t>1/27/13</a:t>
             </a:fld>
             <a:endParaRPr lang="en-US"/>
           </a:p>
@@ -2853,9 +3059,10 @@
           <a:lstStyle/>
           <a:p>
             <a:r>
-              <a:rPr lang="en-US"/>
+              <a:rPr lang="en-US" smtClean="0"/>
               <a:t>Click to edit Master title style</a:t>
             </a:r>
+            <a:endParaRPr lang="en-US"/>
           </a:p>
         </p:txBody>
       </p:sp>
@@ -2876,7 +3083,7 @@
           <a:p>
             <a:fld id="{5BCAD085-E8A6-8845-BD4E-CB4CCA059FC4}" type="datetimeFigureOut">
               <a:rPr lang="en-US" smtClean="0"/>
-              <a:t>5/3/2026</a:t>
+              <a:t>1/27/13</a:t>
             </a:fld>
             <a:endParaRPr lang="en-US"/>
           </a:p>
@@ -2971,7 +3178,7 @@
           <a:p>
             <a:fld id="{5BCAD085-E8A6-8845-BD4E-CB4CCA059FC4}" type="datetimeFigureOut">
               <a:rPr lang="en-US" smtClean="0"/>
-              <a:t>5/3/2026</a:t>
+              <a:t>1/27/13</a:t>
             </a:fld>
             <a:endParaRPr lang="en-US"/>
           </a:p>
@@ -3074,9 +3281,10 @@
           </a:lstStyle>
           <a:p>
             <a:r>
-              <a:rPr lang="en-US"/>
+              <a:rPr lang="en-US" smtClean="0"/>
               <a:t>Click to edit Master title style</a:t>
             </a:r>
+            <a:endParaRPr lang="en-US"/>
           </a:p>
         </p:txBody>
       </p:sp>
@@ -3130,37 +3338,38 @@
           <a:p>
             <a:pPr lvl="0"/>
             <a:r>
-              <a:rPr lang="en-US"/>
+              <a:rPr lang="en-US" smtClean="0"/>
               <a:t>Click to edit Master text styles</a:t>
             </a:r>
           </a:p>
           <a:p>
             <a:pPr lvl="1"/>
             <a:r>
-              <a:rPr lang="en-US"/>
+              <a:rPr lang="en-US" smtClean="0"/>
               <a:t>Second level</a:t>
             </a:r>
           </a:p>
           <a:p>
             <a:pPr lvl="2"/>
             <a:r>
-              <a:rPr lang="en-US"/>
+              <a:rPr lang="en-US" smtClean="0"/>
               <a:t>Third level</a:t>
             </a:r>
           </a:p>
           <a:p>
             <a:pPr lvl="3"/>
             <a:r>
-              <a:rPr lang="en-US"/>
+              <a:rPr lang="en-US" smtClean="0"/>
               <a:t>Fourth level</a:t>
             </a:r>
           </a:p>
           <a:p>
             <a:pPr lvl="4"/>
             <a:r>
-              <a:rPr lang="en-US"/>
+              <a:rPr lang="en-US" smtClean="0"/>
               <a:t>Fifth level</a:t>
             </a:r>
+            <a:endParaRPr lang="en-US"/>
           </a:p>
         </p:txBody>
       </p:sp>
@@ -3223,7 +3432,7 @@
           <a:p>
             <a:pPr lvl="0"/>
             <a:r>
-              <a:rPr lang="en-US"/>
+              <a:rPr lang="en-US" smtClean="0"/>
               <a:t>Click to edit Master text styles</a:t>
             </a:r>
           </a:p>
@@ -3246,7 +3455,7 @@
           <a:p>
             <a:fld id="{5BCAD085-E8A6-8845-BD4E-CB4CCA059FC4}" type="datetimeFigureOut">
               <a:rPr lang="en-US" smtClean="0"/>
-              <a:t>5/3/2026</a:t>
+              <a:t>1/27/13</a:t>
             </a:fld>
             <a:endParaRPr lang="en-US"/>
           </a:p>
@@ -3349,9 +3558,10 @@
           </a:lstStyle>
           <a:p>
             <a:r>
-              <a:rPr lang="en-US"/>
+              <a:rPr lang="en-US" smtClean="0"/>
               <a:t>Click to edit Master title style</a:t>
             </a:r>
+            <a:endParaRPr lang="en-US"/>
           </a:p>
         </p:txBody>
       </p:sp>
@@ -3475,7 +3685,7 @@
           <a:p>
             <a:pPr lvl="0"/>
             <a:r>
-              <a:rPr lang="en-US"/>
+              <a:rPr lang="en-US" smtClean="0"/>
               <a:t>Click to edit Master text styles</a:t>
             </a:r>
           </a:p>
@@ -3498,7 +3708,7 @@
           <a:p>
             <a:fld id="{5BCAD085-E8A6-8845-BD4E-CB4CCA059FC4}" type="datetimeFigureOut">
               <a:rPr lang="en-US" smtClean="0"/>
-              <a:t>5/3/2026</a:t>
+              <a:t>1/27/13</a:t>
             </a:fld>
             <a:endParaRPr lang="en-US"/>
           </a:p>
@@ -3607,9 +3817,10 @@
           <a:lstStyle/>
           <a:p>
             <a:r>
-              <a:rPr lang="en-US"/>
+              <a:rPr lang="en-US" smtClean="0"/>
               <a:t>Click to edit Master title style</a:t>
             </a:r>
+            <a:endParaRPr lang="en-US"/>
           </a:p>
         </p:txBody>
       </p:sp>
@@ -3640,37 +3851,38 @@
           <a:p>
             <a:pPr lvl="0"/>
             <a:r>
-              <a:rPr lang="en-US"/>
+              <a:rPr lang="en-US" smtClean="0"/>
               <a:t>Click to edit Master text styles</a:t>
             </a:r>
           </a:p>
           <a:p>
             <a:pPr lvl="1"/>
             <a:r>
-              <a:rPr lang="en-US"/>
+              <a:rPr lang="en-US" smtClean="0"/>
               <a:t>Second level</a:t>
             </a:r>
           </a:p>
           <a:p>
             <a:pPr lvl="2"/>
             <a:r>
-              <a:rPr lang="en-US"/>
+              <a:rPr lang="en-US" smtClean="0"/>
               <a:t>Third level</a:t>
             </a:r>
           </a:p>
           <a:p>
             <a:pPr lvl="3"/>
             <a:r>
-              <a:rPr lang="en-US"/>
+              <a:rPr lang="en-US" smtClean="0"/>
               <a:t>Fourth level</a:t>
             </a:r>
           </a:p>
           <a:p>
             <a:pPr lvl="4"/>
             <a:r>
-              <a:rPr lang="en-US"/>
+              <a:rPr lang="en-US" smtClean="0"/>
               <a:t>Fifth level</a:t>
             </a:r>
+            <a:endParaRPr lang="en-US"/>
           </a:p>
         </p:txBody>
       </p:sp>
@@ -3709,7 +3921,7 @@
           <a:p>
             <a:fld id="{5BCAD085-E8A6-8845-BD4E-CB4CCA059FC4}" type="datetimeFigureOut">
               <a:rPr lang="en-US" smtClean="0"/>
-              <a:t>5/3/2026</a:t>
+              <a:t>1/27/13</a:t>
             </a:fld>
             <a:endParaRPr lang="en-US"/>
           </a:p>
@@ -4068,7 +4280,7 @@
 </file>
 
 <file path=ppt/slides/slide1.xml><?xml version="1.0" encoding="utf-8"?>
-<p:sld xmlns:a="http://schemas.openxmlformats.org/drawingml/2006/main" xmlns:r="http://schemas.openxmlformats.org/officeDocument/2006/relationships" xmlns:p="http://schemas.openxmlformats.org/presentationml/2006/main">
+<p:sld xmlns:a="http://schemas.openxmlformats.org/drawingml/2006/main" xmlns:p="http://schemas.openxmlformats.org/presentationml/2006/main" xmlns:r="http://schemas.openxmlformats.org/officeDocument/2006/relationships">
   <p:cSld>
     <p:bg>
       <p:bgPr>
@@ -4084,14 +4296,7 @@
         <p:cNvGrpSpPr/>
         <p:nvPr/>
       </p:nvGrpSpPr>
-      <p:grpSpPr>
-        <a:xfrm>
-          <a:off x="0" y="0"/>
-          <a:ext cx="0" cy="0"/>
-          <a:chOff x="0" y="0"/>
-          <a:chExt cx="0" cy="0"/>
-        </a:xfrm>
-      </p:grpSpPr>
+      <p:grpSpPr/>
       <p:sp>
         <p:nvSpPr>
           <p:cNvPr id="2" name="Rectangle 1"/>
@@ -4132,7 +4337,6 @@
           <a:lstStyle/>
           <a:p>
             <a:pPr algn="ctr"/>
-            <a:endParaRPr/>
           </a:p>
         </p:txBody>
       </p:sp>
@@ -4248,7 +4452,6 @@
           <a:lstStyle/>
           <a:p>
             <a:pPr algn="ctr"/>
-            <a:endParaRPr/>
           </a:p>
         </p:txBody>
       </p:sp>
@@ -4400,7 +4603,6 @@
           <a:lstStyle/>
           <a:p>
             <a:pPr algn="ctr"/>
-            <a:endParaRPr/>
           </a:p>
         </p:txBody>
       </p:sp>
@@ -4413,7 +4615,7 @@
 </file>
 
 <file path=ppt/slides/slide10.xml><?xml version="1.0" encoding="utf-8"?>
-<p:sld xmlns:a="http://schemas.openxmlformats.org/drawingml/2006/main" xmlns:r="http://schemas.openxmlformats.org/officeDocument/2006/relationships" xmlns:p="http://schemas.openxmlformats.org/presentationml/2006/main">
+<p:sld xmlns:a="http://schemas.openxmlformats.org/drawingml/2006/main" xmlns:p="http://schemas.openxmlformats.org/presentationml/2006/main" xmlns:r="http://schemas.openxmlformats.org/officeDocument/2006/relationships">
   <p:cSld>
     <p:bg>
       <p:bgPr>
@@ -4429,14 +4631,7 @@
         <p:cNvGrpSpPr/>
         <p:nvPr/>
       </p:nvGrpSpPr>
-      <p:grpSpPr>
-        <a:xfrm>
-          <a:off x="0" y="0"/>
-          <a:ext cx="0" cy="0"/>
-          <a:chOff x="0" y="0"/>
-          <a:chExt cx="0" cy="0"/>
-        </a:xfrm>
-      </p:grpSpPr>
+      <p:grpSpPr/>
       <p:sp>
         <p:nvSpPr>
           <p:cNvPr id="2" name="TextBox 1"/>
@@ -4549,7 +4744,6 @@
           <a:lstStyle/>
           <a:p>
             <a:pPr algn="ctr"/>
-            <a:endParaRPr/>
           </a:p>
         </p:txBody>
       </p:sp>
@@ -4593,7 +4787,6 @@
           <a:lstStyle/>
           <a:p>
             <a:pPr algn="ctr"/>
-            <a:endParaRPr/>
           </a:p>
         </p:txBody>
       </p:sp>
@@ -4721,7 +4914,6 @@
           <a:lstStyle/>
           <a:p>
             <a:pPr algn="ctr"/>
-            <a:endParaRPr/>
           </a:p>
         </p:txBody>
       </p:sp>
@@ -4849,7 +5041,6 @@
           <a:lstStyle/>
           <a:p>
             <a:pPr algn="ctr"/>
-            <a:endParaRPr/>
           </a:p>
         </p:txBody>
       </p:sp>
@@ -4977,7 +5168,6 @@
           <a:lstStyle/>
           <a:p>
             <a:pPr algn="ctr"/>
-            <a:endParaRPr/>
           </a:p>
         </p:txBody>
       </p:sp>
@@ -5110,7 +5300,7 @@
 </file>
 
 <file path=ppt/slides/slide11.xml><?xml version="1.0" encoding="utf-8"?>
-<p:sld xmlns:a="http://schemas.openxmlformats.org/drawingml/2006/main" xmlns:r="http://schemas.openxmlformats.org/officeDocument/2006/relationships" xmlns:p="http://schemas.openxmlformats.org/presentationml/2006/main">
+<p:sld xmlns:a="http://schemas.openxmlformats.org/drawingml/2006/main" xmlns:p="http://schemas.openxmlformats.org/presentationml/2006/main" xmlns:r="http://schemas.openxmlformats.org/officeDocument/2006/relationships">
   <p:cSld>
     <p:bg>
       <p:bgPr>
@@ -5126,14 +5316,7 @@
         <p:cNvGrpSpPr/>
         <p:nvPr/>
       </p:nvGrpSpPr>
-      <p:grpSpPr>
-        <a:xfrm>
-          <a:off x="0" y="0"/>
-          <a:ext cx="0" cy="0"/>
-          <a:chOff x="0" y="0"/>
-          <a:chExt cx="0" cy="0"/>
-        </a:xfrm>
-      </p:grpSpPr>
+      <p:grpSpPr/>
       <p:sp>
         <p:nvSpPr>
           <p:cNvPr id="2" name="TextBox 1"/>
@@ -5246,7 +5429,6 @@
           <a:lstStyle/>
           <a:p>
             <a:pPr algn="ctr"/>
-            <a:endParaRPr/>
           </a:p>
         </p:txBody>
       </p:sp>
@@ -5259,7 +5441,7 @@
         <p:spPr>
           <a:xfrm>
             <a:off x="731520" y="1828800"/>
-            <a:ext cx="10515600" cy="1887696"/>
+            <a:ext cx="10515600" cy="4114800"/>
           </a:xfrm>
           <a:prstGeom prst="rect">
             <a:avLst/>
@@ -5282,9 +5464,13 @@
                 </a:solidFill>
                 <a:latin typeface="Calibri"/>
               </a:defRPr>
-            </a:pPr>
-            <a:r>
-              <a:rPr dirty="0"/>
+              <a:buChar char="●"/>
+              <a:buClr>
+                <a:srgbClr val="2E86C1"/>
+              </a:buClr>
+              <a:buSzPct val="70000"/>
+            </a:pPr>
+            <a:r>
               <a:t>Small dataset: only 69 users — models have limited learning capacity</a:t>
             </a:r>
           </a:p>
@@ -5299,10 +5485,14 @@
                 </a:solidFill>
                 <a:latin typeface="Calibri"/>
               </a:defRPr>
-            </a:pPr>
-            <a:r>
-              <a:rPr dirty="0"/>
-              <a:t>Feature dimensionality: 29 features on 69 users pushes model capacity</a:t>
+              <a:buChar char="●"/>
+              <a:buClr>
+                <a:srgbClr val="2E86C1"/>
+              </a:buClr>
+              <a:buSzPct val="70000"/>
+            </a:pPr>
+            <a:r>
+              <a:t>Proxy demographics: 59/69 are derived from observed distributions — dampens real demographic signal</a:t>
             </a:r>
           </a:p>
           <a:p>
@@ -5316,10 +5506,14 @@
                 </a:solidFill>
                 <a:latin typeface="Calibri"/>
               </a:defRPr>
-            </a:pPr>
-            <a:r>
-              <a:rPr dirty="0"/>
-              <a:t>No temporal split: random split doesn’t simulate real deployment</a:t>
+              <a:buChar char="●"/>
+              <a:buClr>
+                <a:srgbClr val="2E86C1"/>
+              </a:buClr>
+              <a:buSzPct val="70000"/>
+            </a:pPr>
+            <a:r>
+              <a:t>Feature dimensionality: 29 features on 69 users pushes model capacity</a:t>
             </a:r>
           </a:p>
           <a:p>
@@ -5333,10 +5527,14 @@
                 </a:solidFill>
                 <a:latin typeface="Calibri"/>
               </a:defRPr>
-            </a:pPr>
-            <a:r>
-              <a:rPr dirty="0"/>
-              <a:t>Leakage tradeoff: excluding frequency features limits maximum performance</a:t>
+              <a:buChar char="●"/>
+              <a:buClr>
+                <a:srgbClr val="2E86C1"/>
+              </a:buClr>
+              <a:buSzPct val="70000"/>
+            </a:pPr>
+            <a:r>
+              <a:t>No temporal split: random split doesn’t simulate real deployment</a:t>
             </a:r>
           </a:p>
           <a:p>
@@ -5350,9 +5548,34 @@
                 </a:solidFill>
                 <a:latin typeface="Calibri"/>
               </a:defRPr>
-            </a:pPr>
-            <a:r>
-              <a:rPr dirty="0"/>
+              <a:buChar char="●"/>
+              <a:buClr>
+                <a:srgbClr val="2E86C1"/>
+              </a:buClr>
+              <a:buSzPct val="70000"/>
+            </a:pPr>
+            <a:r>
+              <a:t>Leakage tradeoff: excluding frequency features limits maximum performance</a:t>
+            </a:r>
+          </a:p>
+          <a:p>
+            <a:pPr>
+              <a:spcAft>
+                <a:spcPts val="800"/>
+              </a:spcAft>
+              <a:defRPr sz="1800">
+                <a:solidFill>
+                  <a:srgbClr val="333333"/>
+                </a:solidFill>
+                <a:latin typeface="Calibri"/>
+              </a:defRPr>
+              <a:buChar char="●"/>
+              <a:buClr>
+                <a:srgbClr val="2E86C1"/>
+              </a:buClr>
+              <a:buSzPct val="70000"/>
+            </a:pPr>
+            <a:r>
               <a:t>Medium class overlap: boundary users are inherently hard to classify</a:t>
             </a:r>
           </a:p>
@@ -5398,7 +5621,6 @@
           <a:lstStyle/>
           <a:p>
             <a:pPr algn="ctr"/>
-            <a:endParaRPr/>
           </a:p>
         </p:txBody>
       </p:sp>
@@ -5483,7 +5705,7 @@
 </file>
 
 <file path=ppt/slides/slide12.xml><?xml version="1.0" encoding="utf-8"?>
-<p:sld xmlns:a="http://schemas.openxmlformats.org/drawingml/2006/main" xmlns:r="http://schemas.openxmlformats.org/officeDocument/2006/relationships" xmlns:p="http://schemas.openxmlformats.org/presentationml/2006/main">
+<p:sld xmlns:a="http://schemas.openxmlformats.org/drawingml/2006/main" xmlns:p="http://schemas.openxmlformats.org/presentationml/2006/main" xmlns:r="http://schemas.openxmlformats.org/officeDocument/2006/relationships">
   <p:cSld>
     <p:bg>
       <p:bgPr>
@@ -5499,14 +5721,7 @@
         <p:cNvGrpSpPr/>
         <p:nvPr/>
       </p:nvGrpSpPr>
-      <p:grpSpPr>
-        <a:xfrm>
-          <a:off x="0" y="0"/>
-          <a:ext cx="0" cy="0"/>
-          <a:chOff x="0" y="0"/>
-          <a:chExt cx="0" cy="0"/>
-        </a:xfrm>
-      </p:grpSpPr>
+      <p:grpSpPr/>
       <p:sp>
         <p:nvSpPr>
           <p:cNvPr id="2" name="TextBox 1"/>
@@ -5583,7 +5798,6 @@
           <a:lstStyle/>
           <a:p>
             <a:pPr algn="ctr"/>
-            <a:endParaRPr/>
           </a:p>
         </p:txBody>
       </p:sp>
@@ -5619,6 +5833,11 @@
                 </a:solidFill>
                 <a:latin typeface="Calibri"/>
               </a:defRPr>
+              <a:buChar char="●"/>
+              <a:buClr>
+                <a:srgbClr val="2E86C1"/>
+              </a:buClr>
+              <a:buSzPct val="70000"/>
             </a:pPr>
             <a:r>
               <a:t>Behavioral features carry genuine predictive signal for user classification</a:t>
@@ -5635,9 +5854,14 @@
                 </a:solidFill>
                 <a:latin typeface="Calibri"/>
               </a:defRPr>
-            </a:pPr>
-            <a:r>
-              <a:t>XGBoost: Test F1 (macro) = 0.570, well above baselines (0.17 / 0.32)</a:t>
+              <a:buChar char="●"/>
+              <a:buClr>
+                <a:srgbClr val="2E86C1"/>
+              </a:buClr>
+              <a:buSzPct val="70000"/>
+            </a:pPr>
+            <a:r>
+              <a:t>Random Forest (behavioral-only): Test F1 (macro) = 0.548, well above baselines (0.14 / 0.28)</a:t>
             </a:r>
           </a:p>
           <a:p>
@@ -5651,9 +5875,14 @@
                 </a:solidFill>
                 <a:latin typeface="Calibri"/>
               </a:defRPr>
-            </a:pPr>
-            <a:r>
-              <a:t>Demographics: mixed impact (+0.05 RF, -0.04 XGBoost) due to 85% simulated data</a:t>
+              <a:buChar char="●"/>
+              <a:buClr>
+                <a:srgbClr val="2E86C1"/>
+              </a:buClr>
+              <a:buSzPct val="70000"/>
+            </a:pPr>
+            <a:r>
+              <a:t>Demographics: mixed impact (+0.085 LR, -0.187 RF, -0.089 XGBoost) due to limited real coverage</a:t>
             </a:r>
           </a:p>
           <a:p>
@@ -5667,6 +5896,11 @@
                 </a:solidFill>
                 <a:latin typeface="Calibri"/>
               </a:defRPr>
+              <a:buChar char="●"/>
+              <a:buClr>
+                <a:srgbClr val="2E86C1"/>
+              </a:buClr>
+              <a:buSzPct val="70000"/>
             </a:pPr>
             <a:r>
               <a:t>Top predictors: deposit %, send/receive ratio, transfer %, transaction amount</a:t>
@@ -5683,6 +5917,11 @@
                 </a:solidFill>
                 <a:latin typeface="Calibri"/>
               </a:defRPr>
+              <a:buChar char="●"/>
+              <a:buClr>
+                <a:srgbClr val="2E86C1"/>
+              </a:buClr>
+              <a:buSzPct val="70000"/>
             </a:pPr>
             <a:r>
               <a:t>Three distinct user profiles identified: power users, regular users, occasional users</a:t>
@@ -5730,7 +5969,6 @@
           <a:lstStyle/>
           <a:p>
             <a:pPr algn="ctr"/>
-            <a:endParaRPr/>
           </a:p>
         </p:txBody>
       </p:sp>
@@ -5846,7 +6084,6 @@
           <a:lstStyle/>
           <a:p>
             <a:pPr algn="ctr"/>
-            <a:endParaRPr/>
           </a:p>
         </p:txBody>
       </p:sp>
@@ -5859,7 +6096,7 @@
 </file>
 
 <file path=ppt/slides/slide2.xml><?xml version="1.0" encoding="utf-8"?>
-<p:sld xmlns:a="http://schemas.openxmlformats.org/drawingml/2006/main" xmlns:r="http://schemas.openxmlformats.org/officeDocument/2006/relationships" xmlns:p="http://schemas.openxmlformats.org/presentationml/2006/main">
+<p:sld xmlns:a="http://schemas.openxmlformats.org/drawingml/2006/main" xmlns:p="http://schemas.openxmlformats.org/presentationml/2006/main" xmlns:r="http://schemas.openxmlformats.org/officeDocument/2006/relationships">
   <p:cSld>
     <p:bg>
       <p:bgPr>
@@ -5875,14 +6112,7 @@
         <p:cNvGrpSpPr/>
         <p:nvPr/>
       </p:nvGrpSpPr>
-      <p:grpSpPr>
-        <a:xfrm>
-          <a:off x="0" y="0"/>
-          <a:ext cx="0" cy="0"/>
-          <a:chOff x="0" y="0"/>
-          <a:chExt cx="0" cy="0"/>
-        </a:xfrm>
-      </p:grpSpPr>
+      <p:grpSpPr/>
       <p:sp>
         <p:nvSpPr>
           <p:cNvPr id="2" name="TextBox 1"/>
@@ -5995,7 +6225,6 @@
           <a:lstStyle/>
           <a:p>
             <a:pPr algn="ctr"/>
-            <a:endParaRPr/>
           </a:p>
         </p:txBody>
       </p:sp>
@@ -6031,6 +6260,11 @@
                 </a:solidFill>
                 <a:latin typeface="Calibri"/>
               </a:defRPr>
+              <a:buChar char="●"/>
+              <a:buClr>
+                <a:srgbClr val="2E86C1"/>
+              </a:buClr>
+              <a:buSzPct val="70000"/>
             </a:pPr>
             <a:r>
               <a:t>Goal: Classify mobile money users into Low / Medium / High activity</a:t>
@@ -6047,6 +6281,11 @@
                 </a:solidFill>
                 <a:latin typeface="Calibri"/>
               </a:defRPr>
+              <a:buChar char="●"/>
+              <a:buClr>
+                <a:srgbClr val="2E86C1"/>
+              </a:buClr>
+              <a:buSzPct val="70000"/>
             </a:pPr>
             <a:r>
               <a:t>Multi-class classification using behavioral + demographic features</a:t>
@@ -6063,6 +6302,11 @@
                 </a:solidFill>
                 <a:latin typeface="Calibri"/>
               </a:defRPr>
+              <a:buChar char="●"/>
+              <a:buClr>
+                <a:srgbClr val="2E86C1"/>
+              </a:buClr>
+              <a:buSzPct val="70000"/>
             </a:pPr>
             <a:r>
               <a:t>Target defined by quantile thresholds on transaction count</a:t>
@@ -6079,6 +6323,11 @@
                 </a:solidFill>
                 <a:latin typeface="Calibri"/>
               </a:defRPr>
+              <a:buChar char="●"/>
+              <a:buClr>
+                <a:srgbClr val="2E86C1"/>
+              </a:buClr>
+              <a:buSzPct val="70000"/>
             </a:pPr>
             <a:r>
               <a:t>Must outperform naive baselines with no data leakage</a:t>
@@ -6095,6 +6344,11 @@
                 </a:solidFill>
                 <a:latin typeface="Calibri"/>
               </a:defRPr>
+              <a:buChar char="●"/>
+              <a:buClr>
+                <a:srgbClr val="2E86C1"/>
+              </a:buClr>
+              <a:buSzPct val="70000"/>
             </a:pPr>
             <a:r>
               <a:t>New: Assess impact of demographic data on classification accuracy</a:t>
@@ -6142,7 +6396,6 @@
           <a:lstStyle/>
           <a:p>
             <a:pPr algn="ctr"/>
-            <a:endParaRPr/>
           </a:p>
         </p:txBody>
       </p:sp>
@@ -6258,7 +6511,6 @@
           <a:lstStyle/>
           <a:p>
             <a:pPr algn="ctr"/>
-            <a:endParaRPr/>
           </a:p>
         </p:txBody>
       </p:sp>
@@ -6374,7 +6626,6 @@
           <a:lstStyle/>
           <a:p>
             <a:pPr algn="ctr"/>
-            <a:endParaRPr/>
           </a:p>
         </p:txBody>
       </p:sp>
@@ -6495,7 +6746,7 @@
 </file>
 
 <file path=ppt/slides/slide3.xml><?xml version="1.0" encoding="utf-8"?>
-<p:sld xmlns:a="http://schemas.openxmlformats.org/drawingml/2006/main" xmlns:r="http://schemas.openxmlformats.org/officeDocument/2006/relationships" xmlns:p="http://schemas.openxmlformats.org/presentationml/2006/main">
+<p:sld xmlns:a="http://schemas.openxmlformats.org/drawingml/2006/main" xmlns:p="http://schemas.openxmlformats.org/presentationml/2006/main" xmlns:r="http://schemas.openxmlformats.org/officeDocument/2006/relationships">
   <p:cSld>
     <p:bg>
       <p:bgPr>
@@ -6511,14 +6762,7 @@
         <p:cNvGrpSpPr/>
         <p:nvPr/>
       </p:nvGrpSpPr>
-      <p:grpSpPr>
-        <a:xfrm>
-          <a:off x="0" y="0"/>
-          <a:ext cx="0" cy="0"/>
-          <a:chOff x="0" y="0"/>
-          <a:chExt cx="0" cy="0"/>
-        </a:xfrm>
-      </p:grpSpPr>
+      <p:grpSpPr/>
       <p:sp>
         <p:nvSpPr>
           <p:cNvPr id="2" name="TextBox 1"/>
@@ -6631,7 +6875,6 @@
           <a:lstStyle/>
           <a:p>
             <a:pPr algn="ctr"/>
-            <a:endParaRPr/>
           </a:p>
         </p:txBody>
       </p:sp>
@@ -6667,6 +6910,11 @@
                 </a:solidFill>
                 <a:latin typeface="Calibri"/>
               </a:defRPr>
+              <a:buChar char="●"/>
+              <a:buClr>
+                <a:srgbClr val="2E86C1"/>
+              </a:buClr>
+              <a:buSzPct val="70000"/>
             </a:pPr>
             <a:r>
               <a:t>20,530 transactions from 69 users (51 original + 18 anonymized)</a:t>
@@ -6683,6 +6931,11 @@
                 </a:solidFill>
                 <a:latin typeface="Calibri"/>
               </a:defRPr>
+              <a:buChar char="●"/>
+              <a:buClr>
+                <a:srgbClr val="2E86C1"/>
+              </a:buClr>
+              <a:buSzPct val="70000"/>
             </a:pPr>
             <a:r>
               <a:t>Date range: 2023–2026 | MobileMoney (96%) + OrangeMoney (4%)</a:t>
@@ -6699,9 +6952,14 @@
                 </a:solidFill>
                 <a:latin typeface="Calibri"/>
               </a:defRPr>
-            </a:pPr>
-            <a:r>
-              <a:t>Demographic questionnaire: 10 users (extended to 69 via simulation)</a:t>
+              <a:buChar char="●"/>
+              <a:buClr>
+                <a:srgbClr val="2E86C1"/>
+              </a:buClr>
+              <a:buSzPct val="70000"/>
+            </a:pPr>
+            <a:r>
+              <a:t>Demographic questionnaire: 10 real responses; remaining rows use proxy demographics</a:t>
             </a:r>
           </a:p>
           <a:p>
@@ -6715,6 +6973,11 @@
                 </a:solidFill>
                 <a:latin typeface="Calibri"/>
               </a:defRPr>
+              <a:buChar char="●"/>
+              <a:buClr>
+                <a:srgbClr val="2E86C1"/>
+              </a:buClr>
+              <a:buSzPct val="70000"/>
             </a:pPr>
             <a:r>
               <a:t>Fields: age, gender, profession, education, income, geography</a:t>
@@ -6731,9 +6994,14 @@
                 </a:solidFill>
                 <a:latin typeface="Calibri"/>
               </a:defRPr>
-            </a:pPr>
-            <a:r>
-              <a:t>All records tagged: real (10) vs simulated (59)</a:t>
+              <a:buChar char="●"/>
+              <a:buClr>
+                <a:srgbClr val="2E86C1"/>
+              </a:buClr>
+              <a:buSzPct val="70000"/>
+            </a:pPr>
+            <a:r>
+              <a:t>All records tagged: real (10) vs proxy (59)</a:t>
             </a:r>
           </a:p>
         </p:txBody>
@@ -6778,7 +7046,6 @@
           <a:lstStyle/>
           <a:p>
             <a:pPr algn="ctr"/>
-            <a:endParaRPr/>
           </a:p>
         </p:txBody>
       </p:sp>
@@ -6894,7 +7161,6 @@
           <a:lstStyle/>
           <a:p>
             <a:pPr algn="ctr"/>
-            <a:endParaRPr/>
           </a:p>
         </p:txBody>
       </p:sp>
@@ -7010,7 +7276,6 @@
           <a:lstStyle/>
           <a:p>
             <a:pPr algn="ctr"/>
-            <a:endParaRPr/>
           </a:p>
         </p:txBody>
       </p:sp>
@@ -7126,7 +7391,6 @@
           <a:lstStyle/>
           <a:p>
             <a:pPr algn="ctr"/>
-            <a:endParaRPr/>
           </a:p>
         </p:txBody>
       </p:sp>
@@ -7247,7 +7511,7 @@
 </file>
 
 <file path=ppt/slides/slide4.xml><?xml version="1.0" encoding="utf-8"?>
-<p:sld xmlns:a="http://schemas.openxmlformats.org/drawingml/2006/main" xmlns:r="http://schemas.openxmlformats.org/officeDocument/2006/relationships" xmlns:p="http://schemas.openxmlformats.org/presentationml/2006/main">
+<p:sld xmlns:a="http://schemas.openxmlformats.org/drawingml/2006/main" xmlns:p="http://schemas.openxmlformats.org/presentationml/2006/main" xmlns:r="http://schemas.openxmlformats.org/officeDocument/2006/relationships">
   <p:cSld>
     <p:bg>
       <p:bgPr>
@@ -7263,14 +7527,7 @@
         <p:cNvGrpSpPr/>
         <p:nvPr/>
       </p:nvGrpSpPr>
-      <p:grpSpPr>
-        <a:xfrm>
-          <a:off x="0" y="0"/>
-          <a:ext cx="0" cy="0"/>
-          <a:chOff x="0" y="0"/>
-          <a:chExt cx="0" cy="0"/>
-        </a:xfrm>
-      </p:grpSpPr>
+      <p:grpSpPr/>
       <p:sp>
         <p:nvSpPr>
           <p:cNvPr id="2" name="TextBox 1"/>
@@ -7383,7 +7640,6 @@
           <a:lstStyle/>
           <a:p>
             <a:pPr algn="ctr"/>
-            <a:endParaRPr/>
           </a:p>
         </p:txBody>
       </p:sp>
@@ -7455,6 +7711,11 @@
                 </a:solidFill>
                 <a:latin typeface="Calibri"/>
               </a:defRPr>
+              <a:buChar char="●"/>
+              <a:buClr>
+                <a:srgbClr val="2E86C1"/>
+              </a:buClr>
+              <a:buSzPct val="70000"/>
             </a:pPr>
             <a:r>
               <a:t>Parsed SMS messages into structured transactions</a:t>
@@ -7471,6 +7732,11 @@
                 </a:solidFill>
                 <a:latin typeface="Calibri"/>
               </a:defRPr>
+              <a:buChar char="●"/>
+              <a:buClr>
+                <a:srgbClr val="2E86C1"/>
+              </a:buClr>
+              <a:buSzPct val="70000"/>
             </a:pPr>
             <a:r>
               <a:t>Standardized 6 transaction types + IN/OUT direction</a:t>
@@ -7487,6 +7753,11 @@
                 </a:solidFill>
                 <a:latin typeface="Calibri"/>
               </a:defRPr>
+              <a:buChar char="●"/>
+              <a:buClr>
+                <a:srgbClr val="2E86C1"/>
+              </a:buClr>
+              <a:buSzPct val="70000"/>
             </a:pPr>
             <a:r>
               <a:t>Engineered 15 user-level features (amounts, timing, ratios)</a:t>
@@ -7503,6 +7774,11 @@
                 </a:solidFill>
                 <a:latin typeface="Calibri"/>
               </a:defRPr>
+              <a:buChar char="●"/>
+              <a:buClr>
+                <a:srgbClr val="2E86C1"/>
+              </a:buClr>
+              <a:buSzPct val="70000"/>
             </a:pPr>
             <a:r>
               <a:t>Excluded leakage features (frequency, velocity, count)</a:t>
@@ -7578,6 +7854,11 @@
                 </a:solidFill>
                 <a:latin typeface="Calibri"/>
               </a:defRPr>
+              <a:buChar char="●"/>
+              <a:buClr>
+                <a:srgbClr val="E67E22"/>
+              </a:buClr>
+              <a:buSzPct val="70000"/>
             </a:pPr>
             <a:r>
               <a:t>Normalized age ranges, gender, income brackets</a:t>
@@ -7594,6 +7875,11 @@
                 </a:solidFill>
                 <a:latin typeface="Calibri"/>
               </a:defRPr>
+              <a:buChar char="●"/>
+              <a:buClr>
+                <a:srgbClr val="E67E22"/>
+              </a:buClr>
+              <a:buSzPct val="70000"/>
             </a:pPr>
             <a:r>
               <a:t>Grouped 8 professions into 5 standard categories</a:t>
@@ -7610,6 +7896,11 @@
                 </a:solidFill>
                 <a:latin typeface="Calibri"/>
               </a:defRPr>
+              <a:buChar char="●"/>
+              <a:buClr>
+                <a:srgbClr val="E67E22"/>
+              </a:buClr>
+              <a:buSzPct val="70000"/>
             </a:pPr>
             <a:r>
               <a:t>Standardized education to 4 levels</a:t>
@@ -7626,6 +7917,11 @@
                 </a:solidFill>
                 <a:latin typeface="Calibri"/>
               </a:defRPr>
+              <a:buChar char="●"/>
+              <a:buClr>
+                <a:srgbClr val="E67E22"/>
+              </a:buClr>
+              <a:buSzPct val="70000"/>
             </a:pPr>
             <a:r>
               <a:t>Fixed encoding issues (Yaoundé), simplified geography</a:t>
@@ -7673,7 +7969,6 @@
           <a:lstStyle/>
           <a:p>
             <a:pPr algn="ctr"/>
-            <a:endParaRPr/>
           </a:p>
         </p:txBody>
       </p:sp>
@@ -7794,7 +8089,7 @@
 </file>
 
 <file path=ppt/slides/slide5.xml><?xml version="1.0" encoding="utf-8"?>
-<p:sld xmlns:a="http://schemas.openxmlformats.org/drawingml/2006/main" xmlns:r="http://schemas.openxmlformats.org/officeDocument/2006/relationships" xmlns:p="http://schemas.openxmlformats.org/presentationml/2006/main">
+<p:sld xmlns:a="http://schemas.openxmlformats.org/drawingml/2006/main" xmlns:p="http://schemas.openxmlformats.org/presentationml/2006/main" xmlns:r="http://schemas.openxmlformats.org/officeDocument/2006/relationships">
   <p:cSld>
     <p:bg>
       <p:bgPr>
@@ -7810,14 +8105,7 @@
         <p:cNvGrpSpPr/>
         <p:nvPr/>
       </p:nvGrpSpPr>
-      <p:grpSpPr>
-        <a:xfrm>
-          <a:off x="0" y="0"/>
-          <a:ext cx="0" cy="0"/>
-          <a:chOff x="0" y="0"/>
-          <a:chExt cx="0" cy="0"/>
-        </a:xfrm>
-      </p:grpSpPr>
+      <p:grpSpPr/>
       <p:sp>
         <p:nvSpPr>
           <p:cNvPr id="2" name="TextBox 1"/>
@@ -7930,7 +8218,6 @@
           <a:lstStyle/>
           <a:p>
             <a:pPr algn="ctr"/>
-            <a:endParaRPr/>
           </a:p>
         </p:txBody>
       </p:sp>
@@ -7966,6 +8253,11 @@
                 </a:solidFill>
                 <a:latin typeface="Calibri"/>
               </a:defRPr>
+              <a:buChar char="●"/>
+              <a:buClr>
+                <a:srgbClr val="2E86C1"/>
+              </a:buClr>
+              <a:buSzPct val="70000"/>
             </a:pPr>
             <a:r>
               <a:t>Micro-transactions dominate: median = 500 XAF (~$0.80), mean = 7,454 XAF (skewness &gt; 12)</a:t>
@@ -7982,6 +8274,11 @@
                 </a:solidFill>
                 <a:latin typeface="Calibri"/>
               </a:defRPr>
+              <a:buChar char="●"/>
+              <a:buClr>
+                <a:srgbClr val="2E86C1"/>
+              </a:buClr>
+              <a:buSzPct val="70000"/>
             </a:pPr>
             <a:r>
               <a:t>77.5% outbound transactions (transfers, airtime, payments)</a:t>
@@ -7998,6 +8295,11 @@
                 </a:solidFill>
                 <a:latin typeface="Calibri"/>
               </a:defRPr>
+              <a:buChar char="●"/>
+              <a:buClr>
+                <a:srgbClr val="2E86C1"/>
+              </a:buClr>
+              <a:buSzPct val="70000"/>
             </a:pPr>
             <a:r>
               <a:t>Evening peak (17:00–20:00) consistent across all days</a:t>
@@ -8014,6 +8316,11 @@
                 </a:solidFill>
                 <a:latin typeface="Calibri"/>
               </a:defRPr>
+              <a:buChar char="●"/>
+              <a:buClr>
+                <a:srgbClr val="2E86C1"/>
+              </a:buClr>
+              <a:buSzPct val="70000"/>
             </a:pPr>
             <a:r>
               <a:t>High-activity users: many small transactions; Low-activity: fewer but larger</a:t>
@@ -8030,6 +8337,11 @@
                 </a:solidFill>
                 <a:latin typeface="Calibri"/>
               </a:defRPr>
+              <a:buChar char="●"/>
+              <a:buClr>
+                <a:srgbClr val="2E86C1"/>
+              </a:buClr>
+              <a:buSzPct val="70000"/>
             </a:pPr>
             <a:r>
               <a:t>Balanced classes: ~23 users per activity level (quantile-based split)</a:t>
@@ -8077,7 +8389,6 @@
           <a:lstStyle/>
           <a:p>
             <a:pPr algn="ctr"/>
-            <a:endParaRPr/>
           </a:p>
         </p:txBody>
       </p:sp>
@@ -8162,7 +8473,7 @@
 </file>
 
 <file path=ppt/slides/slide6.xml><?xml version="1.0" encoding="utf-8"?>
-<p:sld xmlns:a="http://schemas.openxmlformats.org/drawingml/2006/main" xmlns:r="http://schemas.openxmlformats.org/officeDocument/2006/relationships" xmlns:p="http://schemas.openxmlformats.org/presentationml/2006/main">
+<p:sld xmlns:a="http://schemas.openxmlformats.org/drawingml/2006/main" xmlns:p="http://schemas.openxmlformats.org/presentationml/2006/main" xmlns:r="http://schemas.openxmlformats.org/officeDocument/2006/relationships">
   <p:cSld>
     <p:bg>
       <p:bgPr>
@@ -8178,14 +8489,7 @@
         <p:cNvGrpSpPr/>
         <p:nvPr/>
       </p:nvGrpSpPr>
-      <p:grpSpPr>
-        <a:xfrm>
-          <a:off x="0" y="0"/>
-          <a:ext cx="0" cy="0"/>
-          <a:chOff x="0" y="0"/>
-          <a:chExt cx="0" cy="0"/>
-        </a:xfrm>
-      </p:grpSpPr>
+      <p:grpSpPr/>
       <p:sp>
         <p:nvSpPr>
           <p:cNvPr id="2" name="TextBox 1"/>
@@ -8298,7 +8602,6 @@
           <a:lstStyle/>
           <a:p>
             <a:pPr algn="ctr"/>
-            <a:endParaRPr/>
           </a:p>
         </p:txBody>
       </p:sp>
@@ -8342,7 +8645,6 @@
           <a:lstStyle/>
           <a:p>
             <a:pPr algn="ctr"/>
-            <a:endParaRPr/>
           </a:p>
         </p:txBody>
       </p:sp>
@@ -8466,7 +8768,6 @@
           <a:lstStyle/>
           <a:p>
             <a:pPr algn="ctr"/>
-            <a:endParaRPr/>
           </a:p>
         </p:txBody>
       </p:sp>
@@ -8590,7 +8891,6 @@
           <a:lstStyle/>
           <a:p>
             <a:pPr algn="ctr"/>
-            <a:endParaRPr/>
           </a:p>
         </p:txBody>
       </p:sp>
@@ -8706,9 +9006,14 @@
                 </a:solidFill>
                 <a:latin typeface="Calibri"/>
               </a:defRPr>
-            </a:pPr>
-            <a:r>
-              <a:t>70/30 stratified split | 5-fold stratified cross-validation</a:t>
+              <a:buChar char="●"/>
+              <a:buClr>
+                <a:srgbClr val="2E86C1"/>
+              </a:buClr>
+              <a:buSzPct val="70000"/>
+            </a:pPr>
+            <a:r>
+              <a:t>70/15/15 stratified split | 5-fold stratified cross-validation</a:t>
             </a:r>
           </a:p>
           <a:p>
@@ -8722,6 +9027,11 @@
                 </a:solidFill>
                 <a:latin typeface="Calibri"/>
               </a:defRPr>
+              <a:buChar char="●"/>
+              <a:buClr>
+                <a:srgbClr val="2E86C1"/>
+              </a:buClr>
+              <a:buSzPct val="70000"/>
             </a:pPr>
             <a:r>
               <a:t>Comparison: Behavioral Only (15 features) vs Behavioral + Demographic (29 features)</a:t>
@@ -8738,6 +9048,11 @@
                 </a:solidFill>
                 <a:latin typeface="Calibri"/>
               </a:defRPr>
+              <a:buChar char="●"/>
+              <a:buClr>
+                <a:srgbClr val="2E86C1"/>
+              </a:buClr>
+              <a:buSzPct val="70000"/>
             </a:pPr>
             <a:r>
               <a:t>Primary metric: Macro F1 (treats all 3 classes equally)</a:t>
@@ -8754,6 +9069,11 @@
                 </a:solidFill>
                 <a:latin typeface="Calibri"/>
               </a:defRPr>
+              <a:buChar char="●"/>
+              <a:buClr>
+                <a:srgbClr val="2E86C1"/>
+              </a:buClr>
+              <a:buSzPct val="70000"/>
             </a:pPr>
             <a:r>
               <a:t>random_state=42 throughout for reproducibility</a:t>
@@ -8806,7 +9126,7 @@
 </file>
 
 <file path=ppt/slides/slide7.xml><?xml version="1.0" encoding="utf-8"?>
-<p:sld xmlns:a="http://schemas.openxmlformats.org/drawingml/2006/main" xmlns:r="http://schemas.openxmlformats.org/officeDocument/2006/relationships" xmlns:p="http://schemas.openxmlformats.org/presentationml/2006/main">
+<p:sld xmlns:a="http://schemas.openxmlformats.org/drawingml/2006/main" xmlns:p="http://schemas.openxmlformats.org/presentationml/2006/main" xmlns:r="http://schemas.openxmlformats.org/officeDocument/2006/relationships">
   <p:cSld>
     <p:bg>
       <p:bgPr>
@@ -8822,14 +9142,7 @@
         <p:cNvGrpSpPr/>
         <p:nvPr/>
       </p:nvGrpSpPr>
-      <p:grpSpPr>
-        <a:xfrm>
-          <a:off x="0" y="0"/>
-          <a:ext cx="0" cy="0"/>
-          <a:chOff x="0" y="0"/>
-          <a:chExt cx="0" cy="0"/>
-        </a:xfrm>
-      </p:grpSpPr>
+      <p:grpSpPr/>
       <p:sp>
         <p:nvSpPr>
           <p:cNvPr id="2" name="TextBox 1"/>
@@ -8942,7 +9255,6 @@
           <a:lstStyle/>
           <a:p>
             <a:pPr algn="ctr"/>
-            <a:endParaRPr/>
           </a:p>
         </p:txBody>
       </p:sp>
@@ -8986,7 +9298,6 @@
           <a:lstStyle/>
           <a:p>
             <a:pPr algn="ctr"/>
-            <a:endParaRPr/>
           </a:p>
         </p:txBody>
       </p:sp>
@@ -9066,7 +9377,6 @@
           <a:lstStyle/>
           <a:p>
             <a:pPr algn="ctr"/>
-            <a:endParaRPr/>
           </a:p>
         </p:txBody>
       </p:sp>
@@ -9146,7 +9456,6 @@
           <a:lstStyle/>
           <a:p>
             <a:pPr algn="ctr"/>
-            <a:endParaRPr/>
           </a:p>
         </p:txBody>
       </p:sp>
@@ -9226,7 +9535,6 @@
           <a:lstStyle/>
           <a:p>
             <a:pPr algn="ctr"/>
-            <a:endParaRPr/>
           </a:p>
         </p:txBody>
       </p:sp>
@@ -9306,7 +9614,6 @@
           <a:lstStyle/>
           <a:p>
             <a:pPr algn="ctr"/>
-            <a:endParaRPr/>
           </a:p>
         </p:txBody>
       </p:sp>
@@ -9386,7 +9693,6 @@
           <a:lstStyle/>
           <a:p>
             <a:pPr algn="ctr"/>
-            <a:endParaRPr/>
           </a:p>
         </p:txBody>
       </p:sp>
@@ -9421,7 +9727,7 @@
               </a:defRPr>
             </a:pPr>
             <a:r>
-              <a:t>0.167</a:t>
+              <a:t>0.143</a:t>
             </a:r>
           </a:p>
         </p:txBody>
@@ -9466,7 +9772,6 @@
           <a:lstStyle/>
           <a:p>
             <a:pPr algn="ctr"/>
-            <a:endParaRPr/>
           </a:p>
         </p:txBody>
       </p:sp>
@@ -9546,7 +9851,6 @@
           <a:lstStyle/>
           <a:p>
             <a:pPr algn="ctr"/>
-            <a:endParaRPr/>
           </a:p>
         </p:txBody>
       </p:sp>
@@ -9626,7 +9930,6 @@
           <a:lstStyle/>
           <a:p>
             <a:pPr algn="ctr"/>
-            <a:endParaRPr/>
           </a:p>
         </p:txBody>
       </p:sp>
@@ -9706,7 +10009,6 @@
           <a:lstStyle/>
           <a:p>
             <a:pPr algn="ctr"/>
-            <a:endParaRPr/>
           </a:p>
         </p:txBody>
       </p:sp>
@@ -9741,7 +10043,7 @@
               </a:defRPr>
             </a:pPr>
             <a:r>
-              <a:t>0.315</a:t>
+              <a:t>0.280</a:t>
             </a:r>
           </a:p>
         </p:txBody>
@@ -9786,7 +10088,6 @@
           <a:lstStyle/>
           <a:p>
             <a:pPr algn="ctr"/>
-            <a:endParaRPr/>
           </a:p>
         </p:txBody>
       </p:sp>
@@ -9866,7 +10167,6 @@
           <a:lstStyle/>
           <a:p>
             <a:pPr algn="ctr"/>
-            <a:endParaRPr/>
           </a:p>
         </p:txBody>
       </p:sp>
@@ -9946,7 +10246,6 @@
           <a:lstStyle/>
           <a:p>
             <a:pPr algn="ctr"/>
-            <a:endParaRPr/>
           </a:p>
         </p:txBody>
       </p:sp>
@@ -10026,7 +10325,6 @@
           <a:lstStyle/>
           <a:p>
             <a:pPr algn="ctr"/>
-            <a:endParaRPr/>
           </a:p>
         </p:txBody>
       </p:sp>
@@ -10061,7 +10359,7 @@
               </a:defRPr>
             </a:pPr>
             <a:r>
-              <a:t>0.430</a:t>
+              <a:t>0.169</a:t>
             </a:r>
           </a:p>
         </p:txBody>
@@ -10106,7 +10404,6 @@
           <a:lstStyle/>
           <a:p>
             <a:pPr algn="ctr"/>
-            <a:endParaRPr/>
           </a:p>
         </p:txBody>
       </p:sp>
@@ -10141,7 +10438,7 @@
               </a:defRPr>
             </a:pPr>
             <a:r>
-              <a:t>0.423</a:t>
+              <a:t>0.255</a:t>
             </a:r>
           </a:p>
         </p:txBody>
@@ -10186,7 +10483,6 @@
           <a:lstStyle/>
           <a:p>
             <a:pPr algn="ctr"/>
-            <a:endParaRPr/>
           </a:p>
         </p:txBody>
       </p:sp>
@@ -10221,7 +10517,7 @@
               </a:defRPr>
             </a:pPr>
             <a:r>
-              <a:t>-0.007</a:t>
+              <a:t>+0.085</a:t>
             </a:r>
           </a:p>
         </p:txBody>
@@ -10266,7 +10562,6 @@
           <a:lstStyle/>
           <a:p>
             <a:pPr algn="ctr"/>
-            <a:endParaRPr/>
           </a:p>
         </p:txBody>
       </p:sp>
@@ -10346,7 +10641,6 @@
           <a:lstStyle/>
           <a:p>
             <a:pPr algn="ctr"/>
-            <a:endParaRPr/>
           </a:p>
         </p:txBody>
       </p:sp>
@@ -10381,7 +10675,7 @@
               </a:defRPr>
             </a:pPr>
             <a:r>
-              <a:t>0.418</a:t>
+              <a:t>0.548</a:t>
             </a:r>
           </a:p>
         </p:txBody>
@@ -10426,7 +10720,6 @@
           <a:lstStyle/>
           <a:p>
             <a:pPr algn="ctr"/>
-            <a:endParaRPr/>
           </a:p>
         </p:txBody>
       </p:sp>
@@ -10461,7 +10754,7 @@
               </a:defRPr>
             </a:pPr>
             <a:r>
-              <a:t>0.470</a:t>
+              <a:t>0.361</a:t>
             </a:r>
           </a:p>
         </p:txBody>
@@ -10506,7 +10799,6 @@
           <a:lstStyle/>
           <a:p>
             <a:pPr algn="ctr"/>
-            <a:endParaRPr/>
           </a:p>
         </p:txBody>
       </p:sp>
@@ -10541,7 +10833,7 @@
               </a:defRPr>
             </a:pPr>
             <a:r>
-              <a:t>+0.052</a:t>
+              <a:t>-0.187</a:t>
             </a:r>
           </a:p>
         </p:txBody>
@@ -10586,7 +10878,6 @@
           <a:lstStyle/>
           <a:p>
             <a:pPr algn="ctr"/>
-            <a:endParaRPr/>
           </a:p>
         </p:txBody>
       </p:sp>
@@ -10666,7 +10957,6 @@
           <a:lstStyle/>
           <a:p>
             <a:pPr algn="ctr"/>
-            <a:endParaRPr/>
           </a:p>
         </p:txBody>
       </p:sp>
@@ -10701,7 +10991,7 @@
               </a:defRPr>
             </a:pPr>
             <a:r>
-              <a:t>0.570</a:t>
+              <a:t>0.450</a:t>
             </a:r>
           </a:p>
         </p:txBody>
@@ -10746,7 +11036,6 @@
           <a:lstStyle/>
           <a:p>
             <a:pPr algn="ctr"/>
-            <a:endParaRPr/>
           </a:p>
         </p:txBody>
       </p:sp>
@@ -10781,7 +11070,7 @@
               </a:defRPr>
             </a:pPr>
             <a:r>
-              <a:t>0.529</a:t>
+              <a:t>0.361</a:t>
             </a:r>
           </a:p>
         </p:txBody>
@@ -10826,7 +11115,6 @@
           <a:lstStyle/>
           <a:p>
             <a:pPr algn="ctr"/>
-            <a:endParaRPr/>
           </a:p>
         </p:txBody>
       </p:sp>
@@ -10861,7 +11149,7 @@
               </a:defRPr>
             </a:pPr>
             <a:r>
-              <a:t>-0.041</a:t>
+              <a:t>-0.089</a:t>
             </a:r>
           </a:p>
         </p:txBody>
@@ -10906,7 +11194,6 @@
           <a:lstStyle/>
           <a:p>
             <a:pPr algn="ctr"/>
-            <a:endParaRPr/>
           </a:p>
         </p:txBody>
       </p:sp>
@@ -10941,7 +11228,7 @@
               </a:defRPr>
             </a:pPr>
             <a:r>
-              <a:t>XGBoost (Behavioral Only) leads at F1m = 0.570. Demographics improved RF (+0.05) but slightly decreased XGBoost (-0.04). All trained models exceed both baselines.</a:t>
+              <a:t>Behavioral-only Random Forest leads at F1m = 0.548. Combined features improve Logistic Regression (+0.085) but reduce tree-model performance. All trained models exceed both baselines.</a:t>
             </a:r>
           </a:p>
         </p:txBody>
@@ -10991,7 +11278,7 @@
 </file>
 
 <file path=ppt/slides/slide8.xml><?xml version="1.0" encoding="utf-8"?>
-<p:sld xmlns:a="http://schemas.openxmlformats.org/drawingml/2006/main" xmlns:r="http://schemas.openxmlformats.org/officeDocument/2006/relationships" xmlns:p="http://schemas.openxmlformats.org/presentationml/2006/main">
+<p:sld xmlns:a="http://schemas.openxmlformats.org/drawingml/2006/main" xmlns:p="http://schemas.openxmlformats.org/presentationml/2006/main" xmlns:r="http://schemas.openxmlformats.org/officeDocument/2006/relationships">
   <p:cSld>
     <p:bg>
       <p:bgPr>
@@ -11007,14 +11294,7 @@
         <p:cNvGrpSpPr/>
         <p:nvPr/>
       </p:nvGrpSpPr>
-      <p:grpSpPr>
-        <a:xfrm>
-          <a:off x="0" y="0"/>
-          <a:ext cx="0" cy="0"/>
-          <a:chOff x="0" y="0"/>
-          <a:chExt cx="0" cy="0"/>
-        </a:xfrm>
-      </p:grpSpPr>
+      <p:grpSpPr/>
       <p:sp>
         <p:nvSpPr>
           <p:cNvPr id="2" name="TextBox 1"/>
@@ -11127,7 +11407,6 @@
           <a:lstStyle/>
           <a:p>
             <a:pPr algn="ctr"/>
-            <a:endParaRPr/>
           </a:p>
         </p:txBody>
       </p:sp>
@@ -11199,6 +11478,11 @@
                 </a:solidFill>
                 <a:latin typeface="Calibri"/>
               </a:defRPr>
+              <a:buChar char="●"/>
+              <a:buClr>
+                <a:srgbClr val="2E86C1"/>
+              </a:buClr>
+              <a:buSzPct val="70000"/>
             </a:pPr>
             <a:r>
               <a:t>pct_depot (0.104) — deposit frequency distinguishes levels</a:t>
@@ -11215,6 +11499,11 @@
                 </a:solidFill>
                 <a:latin typeface="Calibri"/>
               </a:defRPr>
+              <a:buChar char="●"/>
+              <a:buClr>
+                <a:srgbClr val="2E86C1"/>
+              </a:buClr>
+              <a:buSzPct val="70000"/>
             </a:pPr>
             <a:r>
               <a:t>avg_sr_ratio (0.052) — send/receive balance</a:t>
@@ -11231,6 +11520,11 @@
                 </a:solidFill>
                 <a:latin typeface="Calibri"/>
               </a:defRPr>
+              <a:buChar char="●"/>
+              <a:buClr>
+                <a:srgbClr val="2E86C1"/>
+              </a:buClr>
+              <a:buSzPct val="70000"/>
             </a:pPr>
             <a:r>
               <a:t>pct_transfert (0.055) — transfer proportion</a:t>
@@ -11247,6 +11541,11 @@
                 </a:solidFill>
                 <a:latin typeface="Calibri"/>
               </a:defRPr>
+              <a:buChar char="●"/>
+              <a:buClr>
+                <a:srgbClr val="2E86C1"/>
+              </a:buClr>
+              <a:buSzPct val="70000"/>
             </a:pPr>
             <a:r>
               <a:t>mean_amount (0.051) — transaction size profile</a:t>
@@ -11263,6 +11562,11 @@
                 </a:solidFill>
                 <a:latin typeface="Calibri"/>
               </a:defRPr>
+              <a:buChar char="●"/>
+              <a:buClr>
+                <a:srgbClr val="2E86C1"/>
+              </a:buClr>
+              <a:buSzPct val="70000"/>
             </a:pPr>
             <a:r>
               <a:t>avg_hour (0.079 RF) — usage timing patterns</a:t>
@@ -11338,6 +11642,11 @@
                 </a:solidFill>
                 <a:latin typeface="Calibri"/>
               </a:defRPr>
+              <a:buChar char="●"/>
+              <a:buClr>
+                <a:srgbClr val="E67E22"/>
+              </a:buClr>
+              <a:buSzPct val="70000"/>
             </a:pPr>
             <a:r>
               <a:t>prof_Unemployed (0.046) — employment status</a:t>
@@ -11354,6 +11663,11 @@
                 </a:solidFill>
                 <a:latin typeface="Calibri"/>
               </a:defRPr>
+              <a:buChar char="●"/>
+              <a:buClr>
+                <a:srgbClr val="E67E22"/>
+              </a:buClr>
+              <a:buSzPct val="70000"/>
             </a:pPr>
             <a:r>
               <a:t>prof_Self-Employed (0.045) — business users</a:t>
@@ -11370,6 +11684,11 @@
                 </a:solidFill>
                 <a:latin typeface="Calibri"/>
               </a:defRPr>
+              <a:buChar char="●"/>
+              <a:buClr>
+                <a:srgbClr val="E67E22"/>
+              </a:buClr>
+              <a:buSzPct val="70000"/>
             </a:pPr>
             <a:r>
               <a:t>education_ordinal (0.044) — education level</a:t>
@@ -11386,6 +11705,11 @@
                 </a:solidFill>
                 <a:latin typeface="Calibri"/>
               </a:defRPr>
+              <a:buChar char="●"/>
+              <a:buClr>
+                <a:srgbClr val="E67E22"/>
+              </a:buClr>
+              <a:buSzPct val="70000"/>
             </a:pPr>
             <a:r>
               <a:t>geo_Urban (0.040) — location type</a:t>
@@ -11402,6 +11726,11 @@
                 </a:solidFill>
                 <a:latin typeface="Calibri"/>
               </a:defRPr>
+              <a:buChar char="●"/>
+              <a:buClr>
+                <a:srgbClr val="E67E22"/>
+              </a:buClr>
+              <a:buSzPct val="70000"/>
             </a:pPr>
             <a:r>
               <a:t>household_size — family network size</a:t>
@@ -11449,7 +11778,6 @@
           <a:lstStyle/>
           <a:p>
             <a:pPr algn="ctr"/>
-            <a:endParaRPr/>
           </a:p>
         </p:txBody>
       </p:sp>
@@ -11534,7 +11862,7 @@
 </file>
 
 <file path=ppt/slides/slide9.xml><?xml version="1.0" encoding="utf-8"?>
-<p:sld xmlns:a="http://schemas.openxmlformats.org/drawingml/2006/main" xmlns:r="http://schemas.openxmlformats.org/officeDocument/2006/relationships" xmlns:p="http://schemas.openxmlformats.org/presentationml/2006/main">
+<p:sld xmlns:a="http://schemas.openxmlformats.org/drawingml/2006/main" xmlns:p="http://schemas.openxmlformats.org/presentationml/2006/main" xmlns:r="http://schemas.openxmlformats.org/officeDocument/2006/relationships">
   <p:cSld>
     <p:bg>
       <p:bgPr>
@@ -11550,14 +11878,7 @@
         <p:cNvGrpSpPr/>
         <p:nvPr/>
       </p:nvGrpSpPr>
-      <p:grpSpPr>
-        <a:xfrm>
-          <a:off x="0" y="0"/>
-          <a:ext cx="0" cy="0"/>
-          <a:chOff x="0" y="0"/>
-          <a:chExt cx="0" cy="0"/>
-        </a:xfrm>
-      </p:grpSpPr>
+      <p:grpSpPr/>
       <p:sp>
         <p:nvSpPr>
           <p:cNvPr id="2" name="TextBox 1"/>
@@ -11634,7 +11955,6 @@
           <a:lstStyle/>
           <a:p>
             <a:pPr algn="ctr"/>
-            <a:endParaRPr/>
           </a:p>
         </p:txBody>
       </p:sp>
@@ -11678,7 +11998,6 @@
           <a:lstStyle/>
           <a:p>
             <a:pPr algn="ctr"/>
-            <a:endParaRPr/>
           </a:p>
         </p:txBody>
       </p:sp>
@@ -11846,7 +12165,6 @@
           <a:lstStyle/>
           <a:p>
             <a:pPr algn="ctr"/>
-            <a:endParaRPr/>
           </a:p>
         </p:txBody>
       </p:sp>
@@ -12014,7 +12332,6 @@
           <a:lstStyle/>
           <a:p>
             <a:pPr algn="ctr"/>
-            <a:endParaRPr/>
           </a:p>
         </p:txBody>
       </p:sp>
@@ -12553,44 +12870,44 @@
         <a:sysClr val="window" lastClr="FFFFFF"/>
       </a:lt1>
       <a:dk2>
-        <a:srgbClr val="0E2841"/>
+        <a:srgbClr val="1F497D"/>
       </a:dk2>
       <a:lt2>
-        <a:srgbClr val="E8E8E8"/>
+        <a:srgbClr val="EEECE1"/>
       </a:lt2>
       <a:accent1>
-        <a:srgbClr val="156082"/>
+        <a:srgbClr val="4F81BD"/>
       </a:accent1>
       <a:accent2>
-        <a:srgbClr val="E97132"/>
+        <a:srgbClr val="C0504D"/>
       </a:accent2>
       <a:accent3>
-        <a:srgbClr val="196B24"/>
+        <a:srgbClr val="9BBB59"/>
       </a:accent3>
       <a:accent4>
-        <a:srgbClr val="0F9ED5"/>
+        <a:srgbClr val="8064A2"/>
       </a:accent4>
       <a:accent5>
-        <a:srgbClr val="A02B93"/>
+        <a:srgbClr val="4BACC6"/>
       </a:accent5>
       <a:accent6>
-        <a:srgbClr val="4EA72E"/>
+        <a:srgbClr val="F79646"/>
       </a:accent6>
       <a:hlink>
-        <a:srgbClr val="467886"/>
+        <a:srgbClr val="0000FF"/>
       </a:hlink>
       <a:folHlink>
-        <a:srgbClr val="96607D"/>
+        <a:srgbClr val="800080"/>
       </a:folHlink>
     </a:clrScheme>
     <a:fontScheme name="Office">
       <a:majorFont>
-        <a:latin typeface="Aptos Display" panose="02110004020202020204"/>
+        <a:latin typeface="Calibri"/>
         <a:ea typeface=""/>
         <a:cs typeface=""/>
-        <a:font script="Jpan" typeface="游ゴシック Light"/>
+        <a:font script="Jpan" typeface="ＭＳ Ｐゴシック"/>
         <a:font script="Hang" typeface="맑은 고딕"/>
-        <a:font script="Hans" typeface="等线 Light"/>
+        <a:font script="Hans" typeface="宋体"/>
         <a:font script="Hant" typeface="新細明體"/>
         <a:font script="Arab" typeface="Times New Roman"/>
         <a:font script="Hebr" typeface="Times New Roman"/>
@@ -12618,31 +12935,14 @@
         <a:font script="Viet" typeface="Times New Roman"/>
         <a:font script="Uigh" typeface="Microsoft Uighur"/>
         <a:font script="Geor" typeface="Sylfaen"/>
-        <a:font script="Armn" typeface="Arial"/>
-        <a:font script="Bugi" typeface="Leelawadee UI"/>
-        <a:font script="Bopo" typeface="Microsoft JhengHei"/>
-        <a:font script="Java" typeface="Javanese Text"/>
-        <a:font script="Lisu" typeface="Segoe UI"/>
-        <a:font script="Mymr" typeface="Myanmar Text"/>
-        <a:font script="Nkoo" typeface="Ebrima"/>
-        <a:font script="Olck" typeface="Nirmala UI"/>
-        <a:font script="Osma" typeface="Ebrima"/>
-        <a:font script="Phag" typeface="Phagspa"/>
-        <a:font script="Syrn" typeface="Estrangelo Edessa"/>
-        <a:font script="Syrj" typeface="Estrangelo Edessa"/>
-        <a:font script="Syre" typeface="Estrangelo Edessa"/>
-        <a:font script="Sora" typeface="Nirmala UI"/>
-        <a:font script="Tale" typeface="Microsoft Tai Le"/>
-        <a:font script="Talu" typeface="Microsoft New Tai Lue"/>
-        <a:font script="Tfng" typeface="Ebrima"/>
       </a:majorFont>
       <a:minorFont>
-        <a:latin typeface="Aptos" panose="02110004020202020204"/>
+        <a:latin typeface="Calibri"/>
         <a:ea typeface=""/>
         <a:cs typeface=""/>
-        <a:font script="Jpan" typeface="游ゴシック"/>
+        <a:font script="Jpan" typeface="ＭＳ Ｐゴシック"/>
         <a:font script="Hang" typeface="맑은 고딕"/>
-        <a:font script="Hans" typeface="等线"/>
+        <a:font script="Hans" typeface="宋体"/>
         <a:font script="Hant" typeface="新細明體"/>
         <a:font script="Arab" typeface="Arial"/>
         <a:font script="Hebr" typeface="Arial"/>
@@ -12670,23 +12970,6 @@
         <a:font script="Viet" typeface="Arial"/>
         <a:font script="Uigh" typeface="Microsoft Uighur"/>
         <a:font script="Geor" typeface="Sylfaen"/>
-        <a:font script="Armn" typeface="Arial"/>
-        <a:font script="Bugi" typeface="Leelawadee UI"/>
-        <a:font script="Bopo" typeface="Microsoft JhengHei"/>
-        <a:font script="Java" typeface="Javanese Text"/>
-        <a:font script="Lisu" typeface="Segoe UI"/>
-        <a:font script="Mymr" typeface="Myanmar Text"/>
-        <a:font script="Nkoo" typeface="Ebrima"/>
-        <a:font script="Olck" typeface="Nirmala UI"/>
-        <a:font script="Osma" typeface="Ebrima"/>
-        <a:font script="Phag" typeface="Phagspa"/>
-        <a:font script="Syrn" typeface="Estrangelo Edessa"/>
-        <a:font script="Syrj" typeface="Estrangelo Edessa"/>
-        <a:font script="Syre" typeface="Estrangelo Edessa"/>
-        <a:font script="Sora" typeface="Nirmala UI"/>
-        <a:font script="Tale" typeface="Microsoft Tai Le"/>
-        <a:font script="Talu" typeface="Microsoft New Tai Lue"/>
-        <a:font script="Tfng" typeface="Ebrima"/>
       </a:minorFont>
     </a:fontScheme>
     <a:fmtScheme name="Office">
@@ -12698,136 +12981,180 @@
           <a:gsLst>
             <a:gs pos="0">
               <a:schemeClr val="phClr">
-                <a:lumMod val="110000"/>
-                <a:satMod val="105000"/>
-                <a:tint val="67000"/>
+                <a:tint val="50000"/>
+                <a:satMod val="300000"/>
               </a:schemeClr>
             </a:gs>
-            <a:gs pos="50000">
+            <a:gs pos="35000">
               <a:schemeClr val="phClr">
-                <a:lumMod val="105000"/>
-                <a:satMod val="103000"/>
-                <a:tint val="73000"/>
+                <a:tint val="37000"/>
+                <a:satMod val="300000"/>
               </a:schemeClr>
             </a:gs>
             <a:gs pos="100000">
               <a:schemeClr val="phClr">
-                <a:lumMod val="105000"/>
-                <a:satMod val="109000"/>
-                <a:tint val="81000"/>
+                <a:tint val="15000"/>
+                <a:satMod val="350000"/>
               </a:schemeClr>
             </a:gs>
           </a:gsLst>
-          <a:lin ang="5400000" scaled="0"/>
+          <a:lin ang="16200000" scaled="1"/>
         </a:gradFill>
         <a:gradFill rotWithShape="1">
           <a:gsLst>
             <a:gs pos="0">
               <a:schemeClr val="phClr">
-                <a:satMod val="103000"/>
-                <a:lumMod val="102000"/>
-                <a:tint val="94000"/>
-              </a:schemeClr>
-            </a:gs>
-            <a:gs pos="50000">
-              <a:schemeClr val="phClr">
-                <a:satMod val="110000"/>
-                <a:lumMod val="100000"/>
+                <a:tint val="100000"/>
                 <a:shade val="100000"/>
+                <a:satMod val="130000"/>
               </a:schemeClr>
             </a:gs>
             <a:gs pos="100000">
               <a:schemeClr val="phClr">
-                <a:lumMod val="99000"/>
-                <a:satMod val="120000"/>
-                <a:shade val="78000"/>
+                <a:tint val="50000"/>
+                <a:shade val="100000"/>
+                <a:satMod val="350000"/>
               </a:schemeClr>
             </a:gs>
           </a:gsLst>
-          <a:lin ang="5400000" scaled="0"/>
+          <a:lin ang="16200000" scaled="0"/>
         </a:gradFill>
       </a:fillStyleLst>
       <a:lnStyleLst>
-        <a:ln w="12700" cap="flat" cmpd="sng" algn="ctr">
+        <a:ln w="9525" cap="flat" cmpd="sng" algn="ctr">
           <a:solidFill>
-            <a:schemeClr val="phClr"/>
+            <a:schemeClr val="phClr">
+              <a:shade val="95000"/>
+              <a:satMod val="105000"/>
+            </a:schemeClr>
           </a:solidFill>
           <a:prstDash val="solid"/>
-          <a:miter lim="800000"/>
-        </a:ln>
-        <a:ln w="19050" cap="flat" cmpd="sng" algn="ctr">
-          <a:solidFill>
-            <a:schemeClr val="phClr"/>
-          </a:solidFill>
-          <a:prstDash val="solid"/>
-          <a:miter lim="800000"/>
         </a:ln>
         <a:ln w="25400" cap="flat" cmpd="sng" algn="ctr">
           <a:solidFill>
             <a:schemeClr val="phClr"/>
           </a:solidFill>
           <a:prstDash val="solid"/>
-          <a:miter lim="800000"/>
+        </a:ln>
+        <a:ln w="38100" cap="flat" cmpd="sng" algn="ctr">
+          <a:solidFill>
+            <a:schemeClr val="phClr"/>
+          </a:solidFill>
+          <a:prstDash val="solid"/>
         </a:ln>
       </a:lnStyleLst>
       <a:effectStyleLst>
         <a:effectStyle>
-          <a:effectLst/>
-        </a:effectStyle>
-        <a:effectStyle>
-          <a:effectLst/>
+          <a:effectLst>
+            <a:outerShdw blurRad="40000" dist="20000" dir="5400000" rotWithShape="0">
+              <a:srgbClr val="000000">
+                <a:alpha val="38000"/>
+              </a:srgbClr>
+            </a:outerShdw>
+          </a:effectLst>
         </a:effectStyle>
         <a:effectStyle>
           <a:effectLst>
-            <a:outerShdw blurRad="57150" dist="19050" dir="5400000" algn="ctr" rotWithShape="0">
+            <a:outerShdw blurRad="40000" dist="23000" dir="5400000" rotWithShape="0">
               <a:srgbClr val="000000">
-                <a:alpha val="63000"/>
+                <a:alpha val="35000"/>
               </a:srgbClr>
             </a:outerShdw>
           </a:effectLst>
+        </a:effectStyle>
+        <a:effectStyle>
+          <a:effectLst>
+            <a:outerShdw blurRad="40000" dist="23000" dir="5400000" rotWithShape="0">
+              <a:srgbClr val="000000">
+                <a:alpha val="35000"/>
+              </a:srgbClr>
+            </a:outerShdw>
+          </a:effectLst>
+          <a:scene3d>
+            <a:camera prst="orthographicFront">
+              <a:rot lat="0" lon="0" rev="0"/>
+            </a:camera>
+            <a:lightRig rig="threePt" dir="t">
+              <a:rot lat="0" lon="0" rev="1200000"/>
+            </a:lightRig>
+          </a:scene3d>
+          <a:sp3d>
+            <a:bevelT w="63500" h="25400"/>
+          </a:sp3d>
         </a:effectStyle>
       </a:effectStyleLst>
       <a:bgFillStyleLst>
         <a:solidFill>
           <a:schemeClr val="phClr"/>
         </a:solidFill>
-        <a:solidFill>
-          <a:schemeClr val="phClr">
-            <a:tint val="95000"/>
-            <a:satMod val="170000"/>
-          </a:schemeClr>
-        </a:solidFill>
         <a:gradFill rotWithShape="1">
           <a:gsLst>
             <a:gs pos="0">
               <a:schemeClr val="phClr">
-                <a:tint val="93000"/>
-                <a:satMod val="150000"/>
-                <a:shade val="98000"/>
-                <a:lumMod val="102000"/>
+                <a:tint val="40000"/>
+                <a:satMod val="350000"/>
               </a:schemeClr>
             </a:gs>
-            <a:gs pos="50000">
+            <a:gs pos="40000">
               <a:schemeClr val="phClr">
-                <a:tint val="98000"/>
-                <a:satMod val="130000"/>
-                <a:shade val="90000"/>
-                <a:lumMod val="103000"/>
+                <a:tint val="45000"/>
+                <a:shade val="99000"/>
+                <a:satMod val="350000"/>
               </a:schemeClr>
             </a:gs>
             <a:gs pos="100000">
               <a:schemeClr val="phClr">
-                <a:shade val="63000"/>
-                <a:satMod val="120000"/>
+                <a:shade val="20000"/>
+                <a:satMod val="255000"/>
               </a:schemeClr>
             </a:gs>
           </a:gsLst>
-          <a:lin ang="5400000" scaled="0"/>
+          <a:path path="circle">
+            <a:fillToRect l="50000" t="-80000" r="50000" b="180000"/>
+          </a:path>
+        </a:gradFill>
+        <a:gradFill rotWithShape="1">
+          <a:gsLst>
+            <a:gs pos="0">
+              <a:schemeClr val="phClr">
+                <a:tint val="80000"/>
+                <a:satMod val="300000"/>
+              </a:schemeClr>
+            </a:gs>
+            <a:gs pos="100000">
+              <a:schemeClr val="phClr">
+                <a:shade val="30000"/>
+                <a:satMod val="200000"/>
+              </a:schemeClr>
+            </a:gs>
+          </a:gsLst>
+          <a:path path="circle">
+            <a:fillToRect l="50000" t="50000" r="50000" b="50000"/>
+          </a:path>
         </a:gradFill>
       </a:bgFillStyleLst>
     </a:fmtScheme>
   </a:themeElements>
   <a:objectDefaults>
+    <a:spDef>
+      <a:spPr/>
+      <a:bodyPr/>
+      <a:lstStyle/>
+      <a:style>
+        <a:lnRef idx="1">
+          <a:schemeClr val="accent1"/>
+        </a:lnRef>
+        <a:fillRef idx="3">
+          <a:schemeClr val="accent1"/>
+        </a:fillRef>
+        <a:effectRef idx="2">
+          <a:schemeClr val="accent1"/>
+        </a:effectRef>
+        <a:fontRef idx="minor">
+          <a:schemeClr val="lt1"/>
+        </a:fontRef>
+      </a:style>
+    </a:spDef>
     <a:lnDef>
       <a:spPr/>
       <a:bodyPr/>
@@ -12849,10 +13176,5 @@
     </a:lnDef>
   </a:objectDefaults>
   <a:extraClrSchemeLst/>
-  <a:extLst>
-    <a:ext uri="{05A4C25C-085E-4340-85A3-A5531E510DB2}">
-      <thm15:themeFamily xmlns:thm15="http://schemas.microsoft.com/office/thememl/2012/main" name="Office Theme" id="{2E142A2C-CD16-42D6-873A-C26D2A0506FA}" vid="{1BDDFF52-6CD6-40A5-AB3C-68EB2F1E4D0A}"/>
-    </a:ext>
-  </a:extLst>
 </a:theme>
 </file>
</xml_diff>